<commit_message>
Redesign slide with cleaner layout and icons
Rebuild the MVP proposal slide so it reads as a consulting deck:
tighter card typography, no clipped body copy, and consistent
line-style icons instead of crude AutoShapes.

Co-authored-by: prasannapanjipalla-coder <prasannapanjipalla-coder@users.noreply.github.com>
</commit_message>
<xml_diff>
--- a/What_We_Are_Proposing.pptx
+++ b/What_We_Are_Proposing.pptx
@@ -3140,8 +3140,8 @@
         </p:nvSpPr>
         <p:spPr>
           <a:xfrm>
-            <a:off x="292608" y="109728"/>
-            <a:ext cx="11612880" cy="384048"/>
+            <a:off x="347472" y="146304"/>
+            <a:ext cx="11494007" cy="365760"/>
           </a:xfrm>
           <a:prstGeom prst="rect">
             <a:avLst/>
@@ -3182,8 +3182,8 @@
         </p:nvSpPr>
         <p:spPr>
           <a:xfrm>
-            <a:off x="292608" y="475488"/>
-            <a:ext cx="11612880" cy="292608"/>
+            <a:off x="347472" y="512064"/>
+            <a:ext cx="11494007" cy="274320"/>
           </a:xfrm>
           <a:prstGeom prst="rect">
             <a:avLst/>
@@ -3203,7 +3203,7 @@
               </a:spcAft>
             </a:pPr>
             <a:r>
-              <a:rPr sz="1200" b="0" i="0">
+              <a:rPr sz="1300" b="0" i="0">
                 <a:solidFill>
                   <a:srgbClr val="4A4A4A"/>
                 </a:solidFill>
@@ -3224,26 +3224,26 @@
         </p:nvSpPr>
         <p:spPr>
           <a:xfrm>
-            <a:off x="292608" y="804672"/>
-            <a:ext cx="3783583" cy="2011680"/>
+            <a:off x="347472" y="841248"/>
+            <a:ext cx="3733799" cy="2029968"/>
           </a:xfrm>
           <a:prstGeom prst="roundRect">
             <a:avLst>
-              <a:gd name="adj" fmla="val 4000"/>
+              <a:gd name="adj" fmla="val 4500"/>
             </a:avLst>
           </a:prstGeom>
           <a:solidFill>
             <a:srgbClr val="FFFFFF"/>
           </a:solidFill>
-          <a:ln w="12700">
+          <a:ln w="9525">
             <a:solidFill>
-              <a:srgbClr val="E4E4E4"/>
+              <a:srgbClr val="E2E2E2"/>
             </a:solidFill>
           </a:ln>
           <a:effectLst>
-            <a:outerShdw blurRad="73152" dist="27432" dir="2700000" algn="tl" rotWithShape="0">
+            <a:outerShdw blurRad="54864" dist="18288" dir="2700000" algn="tl" rotWithShape="0">
               <a:srgbClr val="000000">
-                <a:alpha val="18000"/>
+                <a:alpha val="12000"/>
               </a:srgbClr>
             </a:outerShdw>
           </a:effectLst>
@@ -3272,19 +3272,17 @@
       </p:sp>
       <p:sp>
         <p:nvSpPr>
-          <p:cNvPr id="6" name="Rounded Rectangle 5"/>
+          <p:cNvPr id="6" name="Oval 5"/>
           <p:cNvSpPr/>
           <p:nvPr/>
         </p:nvSpPr>
         <p:spPr>
           <a:xfrm>
-            <a:off x="3589731" y="1009497"/>
-            <a:ext cx="277977" cy="299923"/>
-          </a:xfrm>
-          <a:prstGeom prst="roundRect">
-            <a:avLst>
-              <a:gd name="adj" fmla="val 12000"/>
-            </a:avLst>
+            <a:off x="475488" y="969264"/>
+            <a:ext cx="256032" cy="256032"/>
+          </a:xfrm>
+          <a:prstGeom prst="ellipse">
+            <a:avLst/>
           </a:prstGeom>
           <a:solidFill>
             <a:srgbClr val="D04A02"/>
@@ -3318,382 +3316,83 @@
       </p:sp>
       <p:sp>
         <p:nvSpPr>
-          <p:cNvPr id="7" name="Rounded Rectangle 6"/>
-          <p:cNvSpPr/>
-          <p:nvPr/>
-        </p:nvSpPr>
-        <p:spPr>
-          <a:xfrm>
-            <a:off x="3662883" y="958291"/>
-            <a:ext cx="131673" cy="80467"/>
-          </a:xfrm>
-          <a:prstGeom prst="roundRect">
-            <a:avLst>
-              <a:gd name="adj" fmla="val 30000"/>
-            </a:avLst>
-          </a:prstGeom>
-          <a:solidFill>
-            <a:srgbClr val="D04A02"/>
-          </a:solidFill>
+          <p:cNvPr id="7" name="TextBox 6"/>
+          <p:cNvSpPr txBox="1"/>
+          <p:nvPr/>
+        </p:nvSpPr>
+        <p:spPr>
+          <a:xfrm>
+            <a:off x="475488" y="969264"/>
+            <a:ext cx="256032" cy="256032"/>
+          </a:xfrm>
+          <a:prstGeom prst="rect">
+            <a:avLst/>
+          </a:prstGeom>
+          <a:noFill/>
+        </p:spPr>
+        <p:txBody>
+          <a:bodyPr wrap="square" lIns="0" rIns="0" tIns="0" bIns="0"/>
+          <a:lstStyle/>
+          <a:p>
+            <a:pPr algn="ctr">
+              <a:spcBef>
+                <a:spcPts val="0"/>
+              </a:spcBef>
+              <a:spcAft>
+                <a:spcPts val="0"/>
+              </a:spcAft>
+            </a:pPr>
+            <a:r>
+              <a:rPr sz="1100" b="1" i="0">
+                <a:solidFill>
+                  <a:srgbClr val="FFFFFF"/>
+                </a:solidFill>
+                <a:latin typeface="Calibri"/>
+                <a:ea typeface="Calibri"/>
+                <a:cs typeface="Calibri"/>
+              </a:rPr>
+              <a:t>1</a:t>
+            </a:r>
+          </a:p>
+        </p:txBody>
+      </p:sp>
+      <p:pic>
+        <p:nvPicPr>
+          <p:cNvPr id="8" name="Picture 7" descr="clipboard.png"/>
+          <p:cNvPicPr>
+            <a:picLocks noChangeAspect="1"/>
+          </p:cNvPicPr>
+          <p:nvPr/>
+        </p:nvPicPr>
+        <p:blipFill>
+          <a:blip r:embed="rId2"/>
+          <a:stretch>
+            <a:fillRect/>
+          </a:stretch>
+        </p:blipFill>
+        <p:spPr>
+          <a:xfrm>
+            <a:off x="3624071" y="969264"/>
+            <a:ext cx="310896" cy="310896"/>
+          </a:xfrm>
+          <a:prstGeom prst="rect">
+            <a:avLst/>
+          </a:prstGeom>
           <a:ln>
             <a:noFill/>
           </a:ln>
-          <a:effectLst/>
-        </p:spPr>
-        <p:style>
-          <a:lnRef idx="1">
-            <a:schemeClr val="accent1"/>
-          </a:lnRef>
-          <a:fillRef idx="3">
-            <a:schemeClr val="accent1"/>
-          </a:fillRef>
-          <a:effectRef idx="2">
-            <a:schemeClr val="accent1"/>
-          </a:effectRef>
-          <a:fontRef idx="minor">
-            <a:schemeClr val="lt1"/>
-          </a:fontRef>
-        </p:style>
-        <p:txBody>
-          <a:bodyPr rtlCol="0" anchor="ctr"/>
-          <a:lstStyle/>
-          <a:p>
-            <a:pPr algn="ctr"/>
-          </a:p>
-        </p:txBody>
-      </p:sp>
-      <p:sp>
-        <p:nvSpPr>
-          <p:cNvPr id="8" name="Rounded Rectangle 7"/>
-          <p:cNvSpPr/>
-          <p:nvPr/>
-        </p:nvSpPr>
-        <p:spPr>
-          <a:xfrm>
-            <a:off x="3684828" y="972921"/>
-            <a:ext cx="87782" cy="43891"/>
-          </a:xfrm>
-          <a:prstGeom prst="roundRect">
-            <a:avLst>
-              <a:gd name="adj" fmla="val 30000"/>
-            </a:avLst>
-          </a:prstGeom>
-          <a:solidFill>
-            <a:srgbClr val="FFFFFF"/>
-          </a:solidFill>
-          <a:ln>
-            <a:noFill/>
-          </a:ln>
-          <a:effectLst/>
-        </p:spPr>
-        <p:style>
-          <a:lnRef idx="1">
-            <a:schemeClr val="accent1"/>
-          </a:lnRef>
-          <a:fillRef idx="3">
-            <a:schemeClr val="accent1"/>
-          </a:fillRef>
-          <a:effectRef idx="2">
-            <a:schemeClr val="accent1"/>
-          </a:effectRef>
-          <a:fontRef idx="minor">
-            <a:schemeClr val="lt1"/>
-          </a:fontRef>
-        </p:style>
-        <p:txBody>
-          <a:bodyPr rtlCol="0" anchor="ctr"/>
-          <a:lstStyle/>
-          <a:p>
-            <a:pPr algn="ctr"/>
-          </a:p>
-        </p:txBody>
-      </p:sp>
-      <p:sp>
-        <p:nvSpPr>
-          <p:cNvPr id="9" name="Rounded Rectangle 8"/>
-          <p:cNvSpPr/>
-          <p:nvPr/>
-        </p:nvSpPr>
-        <p:spPr>
-          <a:xfrm>
-            <a:off x="3640937" y="1089964"/>
-            <a:ext cx="36576" cy="36576"/>
-          </a:xfrm>
-          <a:prstGeom prst="roundRect">
-            <a:avLst>
-              <a:gd name="adj" fmla="val 40000"/>
-            </a:avLst>
-          </a:prstGeom>
-          <a:solidFill>
-            <a:srgbClr val="FFFFFF"/>
-          </a:solidFill>
-          <a:ln>
-            <a:noFill/>
-          </a:ln>
-          <a:effectLst/>
-        </p:spPr>
-        <p:style>
-          <a:lnRef idx="1">
-            <a:schemeClr val="accent1"/>
-          </a:lnRef>
-          <a:fillRef idx="3">
-            <a:schemeClr val="accent1"/>
-          </a:fillRef>
-          <a:effectRef idx="2">
-            <a:schemeClr val="accent1"/>
-          </a:effectRef>
-          <a:fontRef idx="minor">
-            <a:schemeClr val="lt1"/>
-          </a:fontRef>
-        </p:style>
-        <p:txBody>
-          <a:bodyPr rtlCol="0" anchor="ctr"/>
-          <a:lstStyle/>
-          <a:p>
-            <a:pPr algn="ctr"/>
-          </a:p>
-        </p:txBody>
-      </p:sp>
-      <p:sp>
-        <p:nvSpPr>
-          <p:cNvPr id="10" name="Rounded Rectangle 9"/>
-          <p:cNvSpPr/>
-          <p:nvPr/>
-        </p:nvSpPr>
-        <p:spPr>
-          <a:xfrm>
-            <a:off x="3699459" y="1097280"/>
-            <a:ext cx="124358" cy="21945"/>
-          </a:xfrm>
-          <a:prstGeom prst="roundRect">
-            <a:avLst>
-              <a:gd name="adj" fmla="val 50000"/>
-            </a:avLst>
-          </a:prstGeom>
-          <a:solidFill>
-            <a:srgbClr val="FFFFFF"/>
-          </a:solidFill>
-          <a:ln>
-            <a:noFill/>
-          </a:ln>
-          <a:effectLst/>
-        </p:spPr>
-        <p:style>
-          <a:lnRef idx="1">
-            <a:schemeClr val="accent1"/>
-          </a:lnRef>
-          <a:fillRef idx="3">
-            <a:schemeClr val="accent1"/>
-          </a:fillRef>
-          <a:effectRef idx="2">
-            <a:schemeClr val="accent1"/>
-          </a:effectRef>
-          <a:fontRef idx="minor">
-            <a:schemeClr val="lt1"/>
-          </a:fontRef>
-        </p:style>
-        <p:txBody>
-          <a:bodyPr rtlCol="0" anchor="ctr"/>
-          <a:lstStyle/>
-          <a:p>
-            <a:pPr algn="ctr"/>
-          </a:p>
-        </p:txBody>
-      </p:sp>
-      <p:sp>
-        <p:nvSpPr>
-          <p:cNvPr id="11" name="Rounded Rectangle 10"/>
-          <p:cNvSpPr/>
-          <p:nvPr/>
-        </p:nvSpPr>
-        <p:spPr>
-          <a:xfrm>
-            <a:off x="3640937" y="1148486"/>
-            <a:ext cx="36576" cy="36576"/>
-          </a:xfrm>
-          <a:prstGeom prst="roundRect">
-            <a:avLst>
-              <a:gd name="adj" fmla="val 40000"/>
-            </a:avLst>
-          </a:prstGeom>
-          <a:solidFill>
-            <a:srgbClr val="FFFFFF"/>
-          </a:solidFill>
-          <a:ln>
-            <a:noFill/>
-          </a:ln>
-          <a:effectLst/>
-        </p:spPr>
-        <p:style>
-          <a:lnRef idx="1">
-            <a:schemeClr val="accent1"/>
-          </a:lnRef>
-          <a:fillRef idx="3">
-            <a:schemeClr val="accent1"/>
-          </a:fillRef>
-          <a:effectRef idx="2">
-            <a:schemeClr val="accent1"/>
-          </a:effectRef>
-          <a:fontRef idx="minor">
-            <a:schemeClr val="lt1"/>
-          </a:fontRef>
-        </p:style>
-        <p:txBody>
-          <a:bodyPr rtlCol="0" anchor="ctr"/>
-          <a:lstStyle/>
-          <a:p>
-            <a:pPr algn="ctr"/>
-          </a:p>
-        </p:txBody>
-      </p:sp>
-      <p:sp>
-        <p:nvSpPr>
-          <p:cNvPr id="12" name="Rounded Rectangle 11"/>
-          <p:cNvSpPr/>
-          <p:nvPr/>
-        </p:nvSpPr>
-        <p:spPr>
-          <a:xfrm>
-            <a:off x="3699459" y="1155801"/>
-            <a:ext cx="124358" cy="21945"/>
-          </a:xfrm>
-          <a:prstGeom prst="roundRect">
-            <a:avLst>
-              <a:gd name="adj" fmla="val 50000"/>
-            </a:avLst>
-          </a:prstGeom>
-          <a:solidFill>
-            <a:srgbClr val="FFFFFF"/>
-          </a:solidFill>
-          <a:ln>
-            <a:noFill/>
-          </a:ln>
-          <a:effectLst/>
-        </p:spPr>
-        <p:style>
-          <a:lnRef idx="1">
-            <a:schemeClr val="accent1"/>
-          </a:lnRef>
-          <a:fillRef idx="3">
-            <a:schemeClr val="accent1"/>
-          </a:fillRef>
-          <a:effectRef idx="2">
-            <a:schemeClr val="accent1"/>
-          </a:effectRef>
-          <a:fontRef idx="minor">
-            <a:schemeClr val="lt1"/>
-          </a:fontRef>
-        </p:style>
-        <p:txBody>
-          <a:bodyPr rtlCol="0" anchor="ctr"/>
-          <a:lstStyle/>
-          <a:p>
-            <a:pPr algn="ctr"/>
-          </a:p>
-        </p:txBody>
-      </p:sp>
-      <p:sp>
-        <p:nvSpPr>
-          <p:cNvPr id="13" name="Rounded Rectangle 12"/>
-          <p:cNvSpPr/>
-          <p:nvPr/>
-        </p:nvSpPr>
-        <p:spPr>
-          <a:xfrm>
-            <a:off x="3640937" y="1207008"/>
-            <a:ext cx="36576" cy="36576"/>
-          </a:xfrm>
-          <a:prstGeom prst="roundRect">
-            <a:avLst>
-              <a:gd name="adj" fmla="val 40000"/>
-            </a:avLst>
-          </a:prstGeom>
-          <a:solidFill>
-            <a:srgbClr val="FFFFFF"/>
-          </a:solidFill>
-          <a:ln>
-            <a:noFill/>
-          </a:ln>
-          <a:effectLst/>
-        </p:spPr>
-        <p:style>
-          <a:lnRef idx="1">
-            <a:schemeClr val="accent1"/>
-          </a:lnRef>
-          <a:fillRef idx="3">
-            <a:schemeClr val="accent1"/>
-          </a:fillRef>
-          <a:effectRef idx="2">
-            <a:schemeClr val="accent1"/>
-          </a:effectRef>
-          <a:fontRef idx="minor">
-            <a:schemeClr val="lt1"/>
-          </a:fontRef>
-        </p:style>
-        <p:txBody>
-          <a:bodyPr rtlCol="0" anchor="ctr"/>
-          <a:lstStyle/>
-          <a:p>
-            <a:pPr algn="ctr"/>
-          </a:p>
-        </p:txBody>
-      </p:sp>
-      <p:sp>
-        <p:nvSpPr>
-          <p:cNvPr id="14" name="Rounded Rectangle 13"/>
-          <p:cNvSpPr/>
-          <p:nvPr/>
-        </p:nvSpPr>
-        <p:spPr>
-          <a:xfrm>
-            <a:off x="3699459" y="1214323"/>
-            <a:ext cx="124358" cy="21945"/>
-          </a:xfrm>
-          <a:prstGeom prst="roundRect">
-            <a:avLst>
-              <a:gd name="adj" fmla="val 50000"/>
-            </a:avLst>
-          </a:prstGeom>
-          <a:solidFill>
-            <a:srgbClr val="FFFFFF"/>
-          </a:solidFill>
-          <a:ln>
-            <a:noFill/>
-          </a:ln>
-          <a:effectLst/>
-        </p:spPr>
-        <p:style>
-          <a:lnRef idx="1">
-            <a:schemeClr val="accent1"/>
-          </a:lnRef>
-          <a:fillRef idx="3">
-            <a:schemeClr val="accent1"/>
-          </a:fillRef>
-          <a:effectRef idx="2">
-            <a:schemeClr val="accent1"/>
-          </a:effectRef>
-          <a:fontRef idx="minor">
-            <a:schemeClr val="lt1"/>
-          </a:fontRef>
-        </p:style>
-        <p:txBody>
-          <a:bodyPr rtlCol="0" anchor="ctr"/>
-          <a:lstStyle/>
-          <a:p>
-            <a:pPr algn="ctr"/>
-          </a:p>
-        </p:txBody>
-      </p:sp>
-      <p:sp>
-        <p:nvSpPr>
-          <p:cNvPr id="15" name="TextBox 14"/>
+        </p:spPr>
+      </p:pic>
+      <p:sp>
+        <p:nvSpPr>
+          <p:cNvPr id="9" name="TextBox 8"/>
           <p:cNvSpPr txBox="1"/>
           <p:nvPr/>
         </p:nvSpPr>
         <p:spPr>
           <a:xfrm>
-            <a:off x="438912" y="950976"/>
-            <a:ext cx="3070351" cy="475488"/>
+            <a:off x="804672" y="950976"/>
+            <a:ext cx="2746247" cy="438912"/>
           </a:xfrm>
           <a:prstGeom prst="rect">
             <a:avLst/>
@@ -3701,7 +3400,7 @@
           <a:noFill/>
         </p:spPr>
         <p:txBody>
-          <a:bodyPr wrap="square" lIns="0" rIns="0" tIns="0" bIns="0"/>
+          <a:bodyPr wrap="square" lIns="18288" rIns="18288" tIns="0" bIns="0"/>
           <a:lstStyle/>
           <a:p>
             <a:pPr algn="l">
@@ -3728,14 +3427,14 @@
       </p:sp>
       <p:sp>
         <p:nvSpPr>
-          <p:cNvPr id="16" name="TextBox 15"/>
+          <p:cNvPr id="10" name="TextBox 9"/>
           <p:cNvSpPr txBox="1"/>
           <p:nvPr/>
         </p:nvSpPr>
         <p:spPr>
           <a:xfrm>
-            <a:off x="402336" y="1444752"/>
-            <a:ext cx="3564127" cy="822960"/>
+            <a:off x="475488" y="1444752"/>
+            <a:ext cx="3477767" cy="1243584"/>
           </a:xfrm>
           <a:prstGeom prst="rect">
             <a:avLst/>
@@ -3743,12 +3442,15 @@
           <a:noFill/>
         </p:spPr>
         <p:txBody>
-          <a:bodyPr wrap="square" lIns="36576" rIns="36576" tIns="18288" bIns="18288">
+          <a:bodyPr wrap="square" lIns="18288" rIns="18288" tIns="0" bIns="0">
             <a:spAutoFit/>
           </a:bodyPr>
           <a:lstStyle/>
           <a:p>
             <a:pPr algn="l">
+              <a:lnSpc>
+                <a:spcPct val="110000"/>
+              </a:lnSpc>
               <a:spcBef>
                 <a:spcPts val="0"/>
               </a:spcBef>
@@ -3757,7 +3459,7 @@
               </a:spcAft>
             </a:pPr>
             <a:r>
-              <a:rPr sz="1100" b="0" i="0">
+              <a:rPr sz="1200" b="0" i="0">
                 <a:solidFill>
                   <a:srgbClr val="4A4A4A"/>
                 </a:solidFill>
@@ -3768,7 +3470,7 @@
               <a:t>Complete labeling requirements while </a:t>
             </a:r>
             <a:r>
-              <a:rPr sz="1100" b="1" i="0">
+              <a:rPr sz="1200" b="1" i="0">
                 <a:solidFill>
                   <a:srgbClr val="4A4A4A"/>
                 </a:solidFill>
@@ -3779,7 +3481,7 @@
               <a:t>pausing</a:t>
             </a:r>
             <a:r>
-              <a:rPr sz="1100" b="0" i="0">
+              <a:rPr sz="1200" b="0" i="0">
                 <a:solidFill>
                   <a:srgbClr val="4A4A4A"/>
                 </a:solidFill>
@@ -3790,7 +3492,7 @@
               <a:t> detailed requirements for other </a:t>
             </a:r>
             <a:r>
-              <a:rPr sz="1100" b="1" i="0">
+              <a:rPr sz="1200" b="1" i="0">
                 <a:solidFill>
                   <a:srgbClr val="4A4A4A"/>
                 </a:solidFill>
@@ -3805,25 +3507,35 @@
       </p:sp>
       <p:sp>
         <p:nvSpPr>
-          <p:cNvPr id="17" name="Oval 16"/>
+          <p:cNvPr id="11" name="Rounded Rectangle 10"/>
           <p:cNvSpPr/>
           <p:nvPr/>
         </p:nvSpPr>
         <p:spPr>
           <a:xfrm>
-            <a:off x="221284" y="715060"/>
-            <a:ext cx="307238" cy="307238"/>
-          </a:xfrm>
-          <a:prstGeom prst="ellipse">
-            <a:avLst/>
+            <a:off x="4227576" y="841248"/>
+            <a:ext cx="3733799" cy="2029968"/>
+          </a:xfrm>
+          <a:prstGeom prst="roundRect">
+            <a:avLst>
+              <a:gd name="adj" fmla="val 4500"/>
+            </a:avLst>
           </a:prstGeom>
           <a:solidFill>
             <a:srgbClr val="FFFFFF"/>
           </a:solidFill>
-          <a:ln>
-            <a:noFill/>
+          <a:ln w="9525">
+            <a:solidFill>
+              <a:srgbClr val="E2E2E2"/>
+            </a:solidFill>
           </a:ln>
-          <a:effectLst/>
+          <a:effectLst>
+            <a:outerShdw blurRad="54864" dist="18288" dir="2700000" algn="tl" rotWithShape="0">
+              <a:srgbClr val="000000">
+                <a:alpha val="12000"/>
+              </a:srgbClr>
+            </a:outerShdw>
+          </a:effectLst>
         </p:spPr>
         <p:style>
           <a:lnRef idx="1">
@@ -3849,14 +3561,14 @@
       </p:sp>
       <p:sp>
         <p:nvSpPr>
-          <p:cNvPr id="18" name="Oval 17"/>
+          <p:cNvPr id="12" name="Oval 11"/>
           <p:cNvSpPr/>
           <p:nvPr/>
         </p:nvSpPr>
         <p:spPr>
           <a:xfrm>
-            <a:off x="237744" y="731520"/>
-            <a:ext cx="274320" cy="274320"/>
+            <a:off x="4355591" y="969264"/>
+            <a:ext cx="256032" cy="256032"/>
           </a:xfrm>
           <a:prstGeom prst="ellipse">
             <a:avLst/>
@@ -3893,14 +3605,14 @@
       </p:sp>
       <p:sp>
         <p:nvSpPr>
-          <p:cNvPr id="19" name="TextBox 18"/>
+          <p:cNvPr id="13" name="TextBox 12"/>
           <p:cNvSpPr txBox="1"/>
           <p:nvPr/>
         </p:nvSpPr>
         <p:spPr>
           <a:xfrm>
-            <a:off x="237744" y="736092"/>
-            <a:ext cx="274320" cy="265176"/>
+            <a:off x="4355591" y="969264"/>
+            <a:ext cx="256032" cy="256032"/>
           </a:xfrm>
           <a:prstGeom prst="rect">
             <a:avLst/>
@@ -3920,7 +3632,7 @@
               </a:spcAft>
             </a:pPr>
             <a:r>
-              <a:rPr sz="1200" b="1" i="0">
+              <a:rPr sz="1100" b="1" i="0">
                 <a:solidFill>
                   <a:srgbClr val="FFFFFF"/>
                 </a:solidFill>
@@ -3928,207 +3640,48 @@
                 <a:ea typeface="Calibri"/>
                 <a:cs typeface="Calibri"/>
               </a:rPr>
-              <a:t>1</a:t>
-            </a:r>
-          </a:p>
-        </p:txBody>
-      </p:sp>
-      <p:sp>
-        <p:nvSpPr>
-          <p:cNvPr id="20" name="Rounded Rectangle 19"/>
-          <p:cNvSpPr/>
-          <p:nvPr/>
-        </p:nvSpPr>
-        <p:spPr>
-          <a:xfrm>
-            <a:off x="4204207" y="804672"/>
-            <a:ext cx="3783583" cy="2011680"/>
-          </a:xfrm>
-          <a:prstGeom prst="roundRect">
-            <a:avLst>
-              <a:gd name="adj" fmla="val 4000"/>
-            </a:avLst>
-          </a:prstGeom>
-          <a:solidFill>
-            <a:srgbClr val="FFFFFF"/>
-          </a:solidFill>
-          <a:ln w="12700">
-            <a:solidFill>
-              <a:srgbClr val="E4E4E4"/>
-            </a:solidFill>
-          </a:ln>
-          <a:effectLst>
-            <a:outerShdw blurRad="73152" dist="27432" dir="2700000" algn="tl" rotWithShape="0">
-              <a:srgbClr val="000000">
-                <a:alpha val="18000"/>
-              </a:srgbClr>
-            </a:outerShdw>
-          </a:effectLst>
-        </p:spPr>
-        <p:style>
-          <a:lnRef idx="1">
-            <a:schemeClr val="accent1"/>
-          </a:lnRef>
-          <a:fillRef idx="3">
-            <a:schemeClr val="accent1"/>
-          </a:fillRef>
-          <a:effectRef idx="2">
-            <a:schemeClr val="accent1"/>
-          </a:effectRef>
-          <a:fontRef idx="minor">
-            <a:schemeClr val="lt1"/>
-          </a:fontRef>
-        </p:style>
-        <p:txBody>
-          <a:bodyPr rtlCol="0" anchor="ctr"/>
-          <a:lstStyle/>
-          <a:p>
-            <a:pPr algn="ctr"/>
-          </a:p>
-        </p:txBody>
-      </p:sp>
-      <p:sp>
-        <p:nvSpPr>
-          <p:cNvPr id="21" name="Oval 20"/>
-          <p:cNvSpPr/>
-          <p:nvPr/>
-        </p:nvSpPr>
-        <p:spPr>
-          <a:xfrm>
-            <a:off x="7457439" y="950976"/>
-            <a:ext cx="365760" cy="365760"/>
-          </a:xfrm>
-          <a:prstGeom prst="ellipse">
+              <a:t>2</a:t>
+            </a:r>
+          </a:p>
+        </p:txBody>
+      </p:sp>
+      <p:pic>
+        <p:nvPicPr>
+          <p:cNvPr id="14" name="Picture 13" descr="target.png"/>
+          <p:cNvPicPr>
+            <a:picLocks noChangeAspect="1"/>
+          </p:cNvPicPr>
+          <p:nvPr/>
+        </p:nvPicPr>
+        <p:blipFill>
+          <a:blip r:embed="rId3"/>
+          <a:stretch>
+            <a:fillRect/>
+          </a:stretch>
+        </p:blipFill>
+        <p:spPr>
+          <a:xfrm>
+            <a:off x="7504176" y="969264"/>
+            <a:ext cx="310896" cy="310896"/>
+          </a:xfrm>
+          <a:prstGeom prst="rect">
             <a:avLst/>
           </a:prstGeom>
-          <a:solidFill>
-            <a:srgbClr val="D04A02"/>
-          </a:solidFill>
           <a:ln>
             <a:noFill/>
           </a:ln>
-          <a:effectLst/>
-        </p:spPr>
-        <p:style>
-          <a:lnRef idx="1">
-            <a:schemeClr val="accent1"/>
-          </a:lnRef>
-          <a:fillRef idx="3">
-            <a:schemeClr val="accent1"/>
-          </a:fillRef>
-          <a:effectRef idx="2">
-            <a:schemeClr val="accent1"/>
-          </a:effectRef>
-          <a:fontRef idx="minor">
-            <a:schemeClr val="lt1"/>
-          </a:fontRef>
-        </p:style>
-        <p:txBody>
-          <a:bodyPr rtlCol="0" anchor="ctr"/>
-          <a:lstStyle/>
-          <a:p>
-            <a:pPr algn="ctr"/>
-          </a:p>
-        </p:txBody>
-      </p:sp>
-      <p:sp>
-        <p:nvSpPr>
-          <p:cNvPr id="22" name="Oval 21"/>
-          <p:cNvSpPr/>
-          <p:nvPr/>
-        </p:nvSpPr>
-        <p:spPr>
-          <a:xfrm>
-            <a:off x="7537906" y="1031443"/>
-            <a:ext cx="204825" cy="204825"/>
-          </a:xfrm>
-          <a:prstGeom prst="ellipse">
-            <a:avLst/>
-          </a:prstGeom>
-          <a:solidFill>
-            <a:srgbClr val="FFFFFF"/>
-          </a:solidFill>
-          <a:ln>
-            <a:noFill/>
-          </a:ln>
-          <a:effectLst/>
-        </p:spPr>
-        <p:style>
-          <a:lnRef idx="1">
-            <a:schemeClr val="accent1"/>
-          </a:lnRef>
-          <a:fillRef idx="3">
-            <a:schemeClr val="accent1"/>
-          </a:fillRef>
-          <a:effectRef idx="2">
-            <a:schemeClr val="accent1"/>
-          </a:effectRef>
-          <a:fontRef idx="minor">
-            <a:schemeClr val="lt1"/>
-          </a:fontRef>
-        </p:style>
-        <p:txBody>
-          <a:bodyPr rtlCol="0" anchor="ctr"/>
-          <a:lstStyle/>
-          <a:p>
-            <a:pPr algn="ctr"/>
-          </a:p>
-        </p:txBody>
-      </p:sp>
-      <p:sp>
-        <p:nvSpPr>
-          <p:cNvPr id="23" name="Oval 22"/>
-          <p:cNvSpPr/>
-          <p:nvPr/>
-        </p:nvSpPr>
-        <p:spPr>
-          <a:xfrm>
-            <a:off x="7589113" y="1082649"/>
-            <a:ext cx="102412" cy="102412"/>
-          </a:xfrm>
-          <a:prstGeom prst="ellipse">
-            <a:avLst/>
-          </a:prstGeom>
-          <a:solidFill>
-            <a:srgbClr val="D04A02"/>
-          </a:solidFill>
-          <a:ln>
-            <a:noFill/>
-          </a:ln>
-          <a:effectLst/>
-        </p:spPr>
-        <p:style>
-          <a:lnRef idx="1">
-            <a:schemeClr val="accent1"/>
-          </a:lnRef>
-          <a:fillRef idx="3">
-            <a:schemeClr val="accent1"/>
-          </a:fillRef>
-          <a:effectRef idx="2">
-            <a:schemeClr val="accent1"/>
-          </a:effectRef>
-          <a:fontRef idx="minor">
-            <a:schemeClr val="lt1"/>
-          </a:fontRef>
-        </p:style>
-        <p:txBody>
-          <a:bodyPr rtlCol="0" anchor="ctr"/>
-          <a:lstStyle/>
-          <a:p>
-            <a:pPr algn="ctr"/>
-          </a:p>
-        </p:txBody>
-      </p:sp>
-      <p:sp>
-        <p:nvSpPr>
-          <p:cNvPr id="24" name="TextBox 23"/>
+        </p:spPr>
+      </p:pic>
+      <p:sp>
+        <p:nvSpPr>
+          <p:cNvPr id="15" name="TextBox 14"/>
           <p:cNvSpPr txBox="1"/>
           <p:nvPr/>
         </p:nvSpPr>
         <p:spPr>
           <a:xfrm>
-            <a:off x="4350511" y="950976"/>
-            <a:ext cx="3070351" cy="475488"/>
+            <a:off x="4684776" y="950976"/>
+            <a:ext cx="2746247" cy="438912"/>
           </a:xfrm>
           <a:prstGeom prst="rect">
             <a:avLst/>
@@ -4136,7 +3689,7 @@
           <a:noFill/>
         </p:spPr>
         <p:txBody>
-          <a:bodyPr wrap="square" lIns="0" rIns="0" tIns="0" bIns="0"/>
+          <a:bodyPr wrap="square" lIns="18288" rIns="18288" tIns="0" bIns="0"/>
           <a:lstStyle/>
           <a:p>
             <a:pPr algn="l">
@@ -4163,14 +3716,14 @@
       </p:sp>
       <p:sp>
         <p:nvSpPr>
-          <p:cNvPr id="25" name="TextBox 24"/>
+          <p:cNvPr id="16" name="TextBox 15"/>
           <p:cNvSpPr txBox="1"/>
           <p:nvPr/>
         </p:nvSpPr>
         <p:spPr>
           <a:xfrm>
-            <a:off x="4313935" y="1444752"/>
-            <a:ext cx="3564127" cy="566928"/>
+            <a:off x="4355591" y="1444752"/>
+            <a:ext cx="3477767" cy="713232"/>
           </a:xfrm>
           <a:prstGeom prst="rect">
             <a:avLst/>
@@ -4178,12 +3731,15 @@
           <a:noFill/>
         </p:spPr>
         <p:txBody>
-          <a:bodyPr wrap="square" lIns="36576" rIns="36576" tIns="18288" bIns="18288">
+          <a:bodyPr wrap="square" lIns="18288" rIns="18288" tIns="0" bIns="0">
             <a:spAutoFit/>
           </a:bodyPr>
           <a:lstStyle/>
           <a:p>
             <a:pPr algn="l">
+              <a:lnSpc>
+                <a:spcPct val="110000"/>
+              </a:lnSpc>
               <a:spcBef>
                 <a:spcPts val="0"/>
               </a:spcBef>
@@ -4192,7 +3748,7 @@
               </a:spcAft>
             </a:pPr>
             <a:r>
-              <a:rPr sz="1100" b="0" i="0">
+              <a:rPr sz="1200" b="0" i="0">
                 <a:solidFill>
                   <a:srgbClr val="4A4A4A"/>
                 </a:solidFill>
@@ -4207,22 +3763,22 @@
       </p:sp>
       <p:sp>
         <p:nvSpPr>
-          <p:cNvPr id="26" name="Rounded Rectangle 25"/>
+          <p:cNvPr id="17" name="Rounded Rectangle 16"/>
           <p:cNvSpPr/>
           <p:nvPr/>
         </p:nvSpPr>
         <p:spPr>
           <a:xfrm>
-            <a:off x="4313935" y="2103120"/>
-            <a:ext cx="3564127" cy="603504"/>
+            <a:off x="4337304" y="2231136"/>
+            <a:ext cx="3514343" cy="548640"/>
           </a:xfrm>
           <a:prstGeom prst="roundRect">
             <a:avLst>
-              <a:gd name="adj" fmla="val 8000"/>
+              <a:gd name="adj" fmla="val 10000"/>
             </a:avLst>
           </a:prstGeom>
           <a:solidFill>
-            <a:srgbClr val="FDF3EC"/>
+            <a:srgbClr val="FDF1E9"/>
           </a:solidFill>
           <a:ln>
             <a:noFill/>
@@ -4251,484 +3807,51 @@
           </a:p>
         </p:txBody>
       </p:sp>
-      <p:sp>
-        <p:nvSpPr>
-          <p:cNvPr id="27" name="Rounded Rectangle 26"/>
-          <p:cNvSpPr/>
-          <p:nvPr/>
-        </p:nvSpPr>
-        <p:spPr>
-          <a:xfrm>
-            <a:off x="4387087" y="2282342"/>
-            <a:ext cx="274320" cy="241401"/>
-          </a:xfrm>
-          <a:prstGeom prst="roundRect">
-            <a:avLst>
-              <a:gd name="adj" fmla="val 12000"/>
-            </a:avLst>
-          </a:prstGeom>
-          <a:solidFill>
-            <a:srgbClr val="FFFFFF"/>
-          </a:solidFill>
-          <a:ln w="12700">
-            <a:solidFill>
-              <a:srgbClr val="D04A02"/>
-            </a:solidFill>
-          </a:ln>
-          <a:effectLst/>
-        </p:spPr>
-        <p:style>
-          <a:lnRef idx="1">
-            <a:schemeClr val="accent1"/>
-          </a:lnRef>
-          <a:fillRef idx="3">
-            <a:schemeClr val="accent1"/>
-          </a:fillRef>
-          <a:effectRef idx="2">
-            <a:schemeClr val="accent1"/>
-          </a:effectRef>
-          <a:fontRef idx="minor">
-            <a:schemeClr val="lt1"/>
-          </a:fontRef>
-        </p:style>
-        <p:txBody>
-          <a:bodyPr rtlCol="0" anchor="ctr"/>
-          <a:lstStyle/>
-          <a:p>
-            <a:pPr algn="ctr"/>
-          </a:p>
-        </p:txBody>
-      </p:sp>
-      <p:sp>
-        <p:nvSpPr>
-          <p:cNvPr id="28" name="Rounded Rectangle 27"/>
-          <p:cNvSpPr/>
-          <p:nvPr/>
-        </p:nvSpPr>
-        <p:spPr>
-          <a:xfrm>
-            <a:off x="4387087" y="2282342"/>
-            <a:ext cx="274320" cy="76809"/>
-          </a:xfrm>
-          <a:prstGeom prst="roundRect">
-            <a:avLst>
-              <a:gd name="adj" fmla="val 12000"/>
-            </a:avLst>
-          </a:prstGeom>
-          <a:solidFill>
-            <a:srgbClr val="D04A02"/>
-          </a:solidFill>
+      <p:pic>
+        <p:nvPicPr>
+          <p:cNvPr id="18" name="Picture 17" descr="calendar.png"/>
+          <p:cNvPicPr>
+            <a:picLocks noChangeAspect="1"/>
+          </p:cNvPicPr>
+          <p:nvPr/>
+        </p:nvPicPr>
+        <p:blipFill>
+          <a:blip r:embed="rId4"/>
+          <a:stretch>
+            <a:fillRect/>
+          </a:stretch>
+        </p:blipFill>
+        <p:spPr>
+          <a:xfrm>
+            <a:off x="4410456" y="2377440"/>
+            <a:ext cx="274320" cy="274320"/>
+          </a:xfrm>
+          <a:prstGeom prst="rect">
+            <a:avLst/>
+          </a:prstGeom>
           <a:ln>
             <a:noFill/>
           </a:ln>
-          <a:effectLst/>
-        </p:spPr>
-        <p:style>
-          <a:lnRef idx="1">
-            <a:schemeClr val="accent1"/>
-          </a:lnRef>
-          <a:fillRef idx="3">
-            <a:schemeClr val="accent1"/>
-          </a:fillRef>
-          <a:effectRef idx="2">
-            <a:schemeClr val="accent1"/>
-          </a:effectRef>
-          <a:fontRef idx="minor">
-            <a:schemeClr val="lt1"/>
-          </a:fontRef>
-        </p:style>
-        <p:txBody>
-          <a:bodyPr rtlCol="0" anchor="ctr"/>
-          <a:lstStyle/>
-          <a:p>
-            <a:pPr algn="ctr"/>
-          </a:p>
-        </p:txBody>
-      </p:sp>
-      <p:sp>
-        <p:nvSpPr>
-          <p:cNvPr id="29" name="Rectangle 28"/>
-          <p:cNvSpPr/>
-          <p:nvPr/>
-        </p:nvSpPr>
-        <p:spPr>
-          <a:xfrm>
-            <a:off x="4387087" y="2326233"/>
-            <a:ext cx="274320" cy="32918"/>
+        </p:spPr>
+      </p:pic>
+      <p:sp>
+        <p:nvSpPr>
+          <p:cNvPr id="19" name="TextBox 18"/>
+          <p:cNvSpPr txBox="1"/>
+          <p:nvPr/>
+        </p:nvSpPr>
+        <p:spPr>
+          <a:xfrm>
+            <a:off x="4721352" y="2276856"/>
+            <a:ext cx="3075432" cy="182880"/>
           </a:xfrm>
           <a:prstGeom prst="rect">
             <a:avLst/>
           </a:prstGeom>
-          <a:solidFill>
-            <a:srgbClr val="D04A02"/>
-          </a:solidFill>
-          <a:ln>
-            <a:noFill/>
-          </a:ln>
-          <a:effectLst/>
-        </p:spPr>
-        <p:style>
-          <a:lnRef idx="1">
-            <a:schemeClr val="accent1"/>
-          </a:lnRef>
-          <a:fillRef idx="3">
-            <a:schemeClr val="accent1"/>
-          </a:fillRef>
-          <a:effectRef idx="2">
-            <a:schemeClr val="accent1"/>
-          </a:effectRef>
-          <a:fontRef idx="minor">
-            <a:schemeClr val="lt1"/>
-          </a:fontRef>
-        </p:style>
-        <p:txBody>
-          <a:bodyPr rtlCol="0" anchor="ctr"/>
-          <a:lstStyle/>
-          <a:p>
-            <a:pPr algn="ctr"/>
-          </a:p>
-        </p:txBody>
-      </p:sp>
-      <p:sp>
-        <p:nvSpPr>
-          <p:cNvPr id="30" name="Rounded Rectangle 29"/>
-          <p:cNvSpPr/>
-          <p:nvPr/>
-        </p:nvSpPr>
-        <p:spPr>
-          <a:xfrm>
-            <a:off x="4447438" y="2249424"/>
-            <a:ext cx="27432" cy="60350"/>
-          </a:xfrm>
-          <a:prstGeom prst="roundRect">
-            <a:avLst>
-              <a:gd name="adj" fmla="val 40000"/>
-            </a:avLst>
-          </a:prstGeom>
-          <a:solidFill>
-            <a:srgbClr val="D04A02"/>
-          </a:solidFill>
-          <a:ln>
-            <a:noFill/>
-          </a:ln>
-          <a:effectLst/>
-        </p:spPr>
-        <p:style>
-          <a:lnRef idx="1">
-            <a:schemeClr val="accent1"/>
-          </a:lnRef>
-          <a:fillRef idx="3">
-            <a:schemeClr val="accent1"/>
-          </a:fillRef>
-          <a:effectRef idx="2">
-            <a:schemeClr val="accent1"/>
-          </a:effectRef>
-          <a:fontRef idx="minor">
-            <a:schemeClr val="lt1"/>
-          </a:fontRef>
-        </p:style>
-        <p:txBody>
-          <a:bodyPr rtlCol="0" anchor="ctr"/>
-          <a:lstStyle/>
-          <a:p>
-            <a:pPr algn="ctr"/>
-          </a:p>
-        </p:txBody>
-      </p:sp>
-      <p:sp>
-        <p:nvSpPr>
-          <p:cNvPr id="31" name="Rounded Rectangle 30"/>
-          <p:cNvSpPr/>
-          <p:nvPr/>
-        </p:nvSpPr>
-        <p:spPr>
-          <a:xfrm>
-            <a:off x="4573625" y="2249424"/>
-            <a:ext cx="27432" cy="60350"/>
-          </a:xfrm>
-          <a:prstGeom prst="roundRect">
-            <a:avLst>
-              <a:gd name="adj" fmla="val 40000"/>
-            </a:avLst>
-          </a:prstGeom>
-          <a:solidFill>
-            <a:srgbClr val="D04A02"/>
-          </a:solidFill>
-          <a:ln>
-            <a:noFill/>
-          </a:ln>
-          <a:effectLst/>
-        </p:spPr>
-        <p:style>
-          <a:lnRef idx="1">
-            <a:schemeClr val="accent1"/>
-          </a:lnRef>
-          <a:fillRef idx="3">
-            <a:schemeClr val="accent1"/>
-          </a:fillRef>
-          <a:effectRef idx="2">
-            <a:schemeClr val="accent1"/>
-          </a:effectRef>
-          <a:fontRef idx="minor">
-            <a:schemeClr val="lt1"/>
-          </a:fontRef>
-        </p:style>
-        <p:txBody>
-          <a:bodyPr rtlCol="0" anchor="ctr"/>
-          <a:lstStyle/>
-          <a:p>
-            <a:pPr algn="ctr"/>
-          </a:p>
-        </p:txBody>
-      </p:sp>
-      <p:sp>
-        <p:nvSpPr>
-          <p:cNvPr id="32" name="Rounded Rectangle 31"/>
-          <p:cNvSpPr/>
-          <p:nvPr/>
-        </p:nvSpPr>
-        <p:spPr>
-          <a:xfrm>
-            <a:off x="4436465" y="2392070"/>
-            <a:ext cx="49377" cy="43891"/>
-          </a:xfrm>
-          <a:prstGeom prst="roundRect">
-            <a:avLst>
-              <a:gd name="adj" fmla="val 30000"/>
-            </a:avLst>
-          </a:prstGeom>
-          <a:solidFill>
-            <a:srgbClr val="FBE8DC"/>
-          </a:solidFill>
-          <a:ln>
-            <a:noFill/>
-          </a:ln>
-          <a:effectLst/>
-        </p:spPr>
-        <p:style>
-          <a:lnRef idx="1">
-            <a:schemeClr val="accent1"/>
-          </a:lnRef>
-          <a:fillRef idx="3">
-            <a:schemeClr val="accent1"/>
-          </a:fillRef>
-          <a:effectRef idx="2">
-            <a:schemeClr val="accent1"/>
-          </a:effectRef>
-          <a:fontRef idx="minor">
-            <a:schemeClr val="lt1"/>
-          </a:fontRef>
-        </p:style>
-        <p:txBody>
-          <a:bodyPr rtlCol="0" anchor="ctr"/>
-          <a:lstStyle/>
-          <a:p>
-            <a:pPr algn="ctr"/>
-          </a:p>
-        </p:txBody>
-      </p:sp>
-      <p:sp>
-        <p:nvSpPr>
-          <p:cNvPr id="33" name="Rounded Rectangle 32"/>
-          <p:cNvSpPr/>
-          <p:nvPr/>
-        </p:nvSpPr>
-        <p:spPr>
-          <a:xfrm>
-            <a:off x="4502302" y="2392070"/>
-            <a:ext cx="49377" cy="43891"/>
-          </a:xfrm>
-          <a:prstGeom prst="roundRect">
-            <a:avLst>
-              <a:gd name="adj" fmla="val 30000"/>
-            </a:avLst>
-          </a:prstGeom>
-          <a:solidFill>
-            <a:srgbClr val="D04A02"/>
-          </a:solidFill>
-          <a:ln>
-            <a:noFill/>
-          </a:ln>
-          <a:effectLst/>
-        </p:spPr>
-        <p:style>
-          <a:lnRef idx="1">
-            <a:schemeClr val="accent1"/>
-          </a:lnRef>
-          <a:fillRef idx="3">
-            <a:schemeClr val="accent1"/>
-          </a:fillRef>
-          <a:effectRef idx="2">
-            <a:schemeClr val="accent1"/>
-          </a:effectRef>
-          <a:fontRef idx="minor">
-            <a:schemeClr val="lt1"/>
-          </a:fontRef>
-        </p:style>
-        <p:txBody>
-          <a:bodyPr rtlCol="0" anchor="ctr"/>
-          <a:lstStyle/>
-          <a:p>
-            <a:pPr algn="ctr"/>
-          </a:p>
-        </p:txBody>
-      </p:sp>
-      <p:sp>
-        <p:nvSpPr>
-          <p:cNvPr id="34" name="Rounded Rectangle 33"/>
-          <p:cNvSpPr/>
-          <p:nvPr/>
-        </p:nvSpPr>
-        <p:spPr>
-          <a:xfrm>
-            <a:off x="4568139" y="2392070"/>
-            <a:ext cx="49377" cy="43891"/>
-          </a:xfrm>
-          <a:prstGeom prst="roundRect">
-            <a:avLst>
-              <a:gd name="adj" fmla="val 30000"/>
-            </a:avLst>
-          </a:prstGeom>
-          <a:solidFill>
-            <a:srgbClr val="FBE8DC"/>
-          </a:solidFill>
-          <a:ln>
-            <a:noFill/>
-          </a:ln>
-          <a:effectLst/>
-        </p:spPr>
-        <p:style>
-          <a:lnRef idx="1">
-            <a:schemeClr val="accent1"/>
-          </a:lnRef>
-          <a:fillRef idx="3">
-            <a:schemeClr val="accent1"/>
-          </a:fillRef>
-          <a:effectRef idx="2">
-            <a:schemeClr val="accent1"/>
-          </a:effectRef>
-          <a:fontRef idx="minor">
-            <a:schemeClr val="lt1"/>
-          </a:fontRef>
-        </p:style>
-        <p:txBody>
-          <a:bodyPr rtlCol="0" anchor="ctr"/>
-          <a:lstStyle/>
-          <a:p>
-            <a:pPr algn="ctr"/>
-          </a:p>
-        </p:txBody>
-      </p:sp>
-      <p:sp>
-        <p:nvSpPr>
-          <p:cNvPr id="35" name="Rounded Rectangle 34"/>
-          <p:cNvSpPr/>
-          <p:nvPr/>
-        </p:nvSpPr>
-        <p:spPr>
-          <a:xfrm>
-            <a:off x="4436465" y="2452420"/>
-            <a:ext cx="49377" cy="43891"/>
-          </a:xfrm>
-          <a:prstGeom prst="roundRect">
-            <a:avLst>
-              <a:gd name="adj" fmla="val 30000"/>
-            </a:avLst>
-          </a:prstGeom>
-          <a:solidFill>
-            <a:srgbClr val="FBE8DC"/>
-          </a:solidFill>
-          <a:ln>
-            <a:noFill/>
-          </a:ln>
-          <a:effectLst/>
-        </p:spPr>
-        <p:style>
-          <a:lnRef idx="1">
-            <a:schemeClr val="accent1"/>
-          </a:lnRef>
-          <a:fillRef idx="3">
-            <a:schemeClr val="accent1"/>
-          </a:fillRef>
-          <a:effectRef idx="2">
-            <a:schemeClr val="accent1"/>
-          </a:effectRef>
-          <a:fontRef idx="minor">
-            <a:schemeClr val="lt1"/>
-          </a:fontRef>
-        </p:style>
-        <p:txBody>
-          <a:bodyPr rtlCol="0" anchor="ctr"/>
-          <a:lstStyle/>
-          <a:p>
-            <a:pPr algn="ctr"/>
-          </a:p>
-        </p:txBody>
-      </p:sp>
-      <p:sp>
-        <p:nvSpPr>
-          <p:cNvPr id="36" name="Rounded Rectangle 35"/>
-          <p:cNvSpPr/>
-          <p:nvPr/>
-        </p:nvSpPr>
-        <p:spPr>
-          <a:xfrm>
-            <a:off x="4502302" y="2452420"/>
-            <a:ext cx="49377" cy="43891"/>
-          </a:xfrm>
-          <a:prstGeom prst="roundRect">
-            <a:avLst>
-              <a:gd name="adj" fmla="val 30000"/>
-            </a:avLst>
-          </a:prstGeom>
-          <a:solidFill>
-            <a:srgbClr val="FBE8DC"/>
-          </a:solidFill>
-          <a:ln>
-            <a:noFill/>
-          </a:ln>
-          <a:effectLst/>
-        </p:spPr>
-        <p:style>
-          <a:lnRef idx="1">
-            <a:schemeClr val="accent1"/>
-          </a:lnRef>
-          <a:fillRef idx="3">
-            <a:schemeClr val="accent1"/>
-          </a:fillRef>
-          <a:effectRef idx="2">
-            <a:schemeClr val="accent1"/>
-          </a:effectRef>
-          <a:fontRef idx="minor">
-            <a:schemeClr val="lt1"/>
-          </a:fontRef>
-        </p:style>
-        <p:txBody>
-          <a:bodyPr rtlCol="0" anchor="ctr"/>
-          <a:lstStyle/>
-          <a:p>
-            <a:pPr algn="ctr"/>
-          </a:p>
-        </p:txBody>
-      </p:sp>
-      <p:sp>
-        <p:nvSpPr>
-          <p:cNvPr id="37" name="TextBox 36"/>
-          <p:cNvSpPr txBox="1"/>
-          <p:nvPr/>
-        </p:nvSpPr>
-        <p:spPr>
-          <a:xfrm>
-            <a:off x="4716271" y="2139696"/>
-            <a:ext cx="3088639" cy="201168"/>
-          </a:xfrm>
-          <a:prstGeom prst="rect">
-            <a:avLst/>
-          </a:prstGeom>
           <a:noFill/>
         </p:spPr>
         <p:txBody>
-          <a:bodyPr wrap="square" lIns="18288" rIns="36576" tIns="18288" bIns="0"/>
+          <a:bodyPr wrap="square" lIns="18288" rIns="36576" tIns="0" bIns="0"/>
           <a:lstStyle/>
           <a:p>
             <a:pPr algn="l">
@@ -4755,14 +3878,14 @@
       </p:sp>
       <p:sp>
         <p:nvSpPr>
-          <p:cNvPr id="38" name="TextBox 37"/>
+          <p:cNvPr id="20" name="TextBox 19"/>
           <p:cNvSpPr txBox="1"/>
           <p:nvPr/>
         </p:nvSpPr>
         <p:spPr>
           <a:xfrm>
-            <a:off x="4716271" y="2322576"/>
-            <a:ext cx="3088639" cy="365760"/>
+            <a:off x="4721352" y="2450592"/>
+            <a:ext cx="3075432" cy="329184"/>
           </a:xfrm>
           <a:prstGeom prst="rect">
             <a:avLst/>
@@ -4797,25 +3920,35 @@
       </p:sp>
       <p:sp>
         <p:nvSpPr>
-          <p:cNvPr id="39" name="Oval 38"/>
+          <p:cNvPr id="21" name="Rounded Rectangle 20"/>
           <p:cNvSpPr/>
           <p:nvPr/>
         </p:nvSpPr>
         <p:spPr>
           <a:xfrm>
-            <a:off x="4132884" y="715060"/>
-            <a:ext cx="307238" cy="307238"/>
-          </a:xfrm>
-          <a:prstGeom prst="ellipse">
-            <a:avLst/>
+            <a:off x="8107680" y="841248"/>
+            <a:ext cx="3733799" cy="2029968"/>
+          </a:xfrm>
+          <a:prstGeom prst="roundRect">
+            <a:avLst>
+              <a:gd name="adj" fmla="val 4500"/>
+            </a:avLst>
           </a:prstGeom>
           <a:solidFill>
             <a:srgbClr val="FFFFFF"/>
           </a:solidFill>
-          <a:ln>
-            <a:noFill/>
+          <a:ln w="9525">
+            <a:solidFill>
+              <a:srgbClr val="E2E2E2"/>
+            </a:solidFill>
           </a:ln>
-          <a:effectLst/>
+          <a:effectLst>
+            <a:outerShdw blurRad="54864" dist="18288" dir="2700000" algn="tl" rotWithShape="0">
+              <a:srgbClr val="000000">
+                <a:alpha val="12000"/>
+              </a:srgbClr>
+            </a:outerShdw>
+          </a:effectLst>
         </p:spPr>
         <p:style>
           <a:lnRef idx="1">
@@ -4841,14 +3974,14 @@
       </p:sp>
       <p:sp>
         <p:nvSpPr>
-          <p:cNvPr id="40" name="Oval 39"/>
+          <p:cNvPr id="22" name="Oval 21"/>
           <p:cNvSpPr/>
           <p:nvPr/>
         </p:nvSpPr>
         <p:spPr>
           <a:xfrm>
-            <a:off x="4149343" y="731520"/>
-            <a:ext cx="274320" cy="274320"/>
+            <a:off x="8235696" y="969264"/>
+            <a:ext cx="256032" cy="256032"/>
           </a:xfrm>
           <a:prstGeom prst="ellipse">
             <a:avLst/>
@@ -4885,14 +4018,14 @@
       </p:sp>
       <p:sp>
         <p:nvSpPr>
-          <p:cNvPr id="41" name="TextBox 40"/>
+          <p:cNvPr id="23" name="TextBox 22"/>
           <p:cNvSpPr txBox="1"/>
           <p:nvPr/>
         </p:nvSpPr>
         <p:spPr>
           <a:xfrm>
-            <a:off x="4149343" y="736092"/>
-            <a:ext cx="274320" cy="265176"/>
+            <a:off x="8235696" y="969264"/>
+            <a:ext cx="256032" cy="256032"/>
           </a:xfrm>
           <a:prstGeom prst="rect">
             <a:avLst/>
@@ -4912,7 +4045,7 @@
               </a:spcAft>
             </a:pPr>
             <a:r>
-              <a:rPr sz="1200" b="1" i="0">
+              <a:rPr sz="1100" b="1" i="0">
                 <a:solidFill>
                   <a:srgbClr val="FFFFFF"/>
                 </a:solidFill>
@@ -4920,207 +4053,48 @@
                 <a:ea typeface="Calibri"/>
                 <a:cs typeface="Calibri"/>
               </a:rPr>
-              <a:t>2</a:t>
-            </a:r>
-          </a:p>
-        </p:txBody>
-      </p:sp>
-      <p:sp>
-        <p:nvSpPr>
-          <p:cNvPr id="42" name="Rounded Rectangle 41"/>
-          <p:cNvSpPr/>
-          <p:nvPr/>
-        </p:nvSpPr>
-        <p:spPr>
-          <a:xfrm>
-            <a:off x="8115807" y="804672"/>
-            <a:ext cx="3783583" cy="2011680"/>
-          </a:xfrm>
-          <a:prstGeom prst="roundRect">
-            <a:avLst>
-              <a:gd name="adj" fmla="val 4000"/>
-            </a:avLst>
-          </a:prstGeom>
-          <a:solidFill>
-            <a:srgbClr val="FFFFFF"/>
-          </a:solidFill>
-          <a:ln w="12700">
-            <a:solidFill>
-              <a:srgbClr val="E4E4E4"/>
-            </a:solidFill>
-          </a:ln>
-          <a:effectLst>
-            <a:outerShdw blurRad="73152" dist="27432" dir="2700000" algn="tl" rotWithShape="0">
-              <a:srgbClr val="000000">
-                <a:alpha val="18000"/>
-              </a:srgbClr>
-            </a:outerShdw>
-          </a:effectLst>
-        </p:spPr>
-        <p:style>
-          <a:lnRef idx="1">
-            <a:schemeClr val="accent1"/>
-          </a:lnRef>
-          <a:fillRef idx="3">
-            <a:schemeClr val="accent1"/>
-          </a:fillRef>
-          <a:effectRef idx="2">
-            <a:schemeClr val="accent1"/>
-          </a:effectRef>
-          <a:fontRef idx="minor">
-            <a:schemeClr val="lt1"/>
-          </a:fontRef>
-        </p:style>
-        <p:txBody>
-          <a:bodyPr rtlCol="0" anchor="ctr"/>
-          <a:lstStyle/>
-          <a:p>
-            <a:pPr algn="ctr"/>
-          </a:p>
-        </p:txBody>
-      </p:sp>
-      <p:sp>
-        <p:nvSpPr>
-          <p:cNvPr id="43" name="Right Arrow 42"/>
-          <p:cNvSpPr/>
-          <p:nvPr/>
-        </p:nvSpPr>
-        <p:spPr>
-          <a:xfrm>
-            <a:off x="11332463" y="987552"/>
-            <a:ext cx="414771" cy="99852"/>
-          </a:xfrm>
-          <a:prstGeom prst="rightArrow">
+              <a:t>3</a:t>
+            </a:r>
+          </a:p>
+        </p:txBody>
+      </p:sp>
+      <p:pic>
+        <p:nvPicPr>
+          <p:cNvPr id="24" name="Picture 23" descr="arrows.png"/>
+          <p:cNvPicPr>
+            <a:picLocks noChangeAspect="1"/>
+          </p:cNvPicPr>
+          <p:nvPr/>
+        </p:nvPicPr>
+        <p:blipFill>
+          <a:blip r:embed="rId5"/>
+          <a:stretch>
+            <a:fillRect/>
+          </a:stretch>
+        </p:blipFill>
+        <p:spPr>
+          <a:xfrm>
+            <a:off x="11384280" y="969264"/>
+            <a:ext cx="310896" cy="310896"/>
+          </a:xfrm>
+          <a:prstGeom prst="rect">
             <a:avLst/>
           </a:prstGeom>
-          <a:solidFill>
-            <a:srgbClr val="D04A02"/>
-          </a:solidFill>
           <a:ln>
             <a:noFill/>
           </a:ln>
-          <a:effectLst/>
-        </p:spPr>
-        <p:style>
-          <a:lnRef idx="1">
-            <a:schemeClr val="accent1"/>
-          </a:lnRef>
-          <a:fillRef idx="3">
-            <a:schemeClr val="accent1"/>
-          </a:fillRef>
-          <a:effectRef idx="2">
-            <a:schemeClr val="accent1"/>
-          </a:effectRef>
-          <a:fontRef idx="minor">
-            <a:schemeClr val="lt1"/>
-          </a:fontRef>
-        </p:style>
-        <p:txBody>
-          <a:bodyPr rtlCol="0" anchor="ctr"/>
-          <a:lstStyle/>
-          <a:p>
-            <a:pPr algn="ctr"/>
-          </a:p>
-        </p:txBody>
-      </p:sp>
-      <p:sp>
-        <p:nvSpPr>
-          <p:cNvPr id="44" name="Right Arrow 43"/>
-          <p:cNvSpPr/>
-          <p:nvPr/>
-        </p:nvSpPr>
-        <p:spPr>
-          <a:xfrm>
-            <a:off x="11332463" y="1118128"/>
-            <a:ext cx="414771" cy="99852"/>
-          </a:xfrm>
-          <a:prstGeom prst="rightArrow">
-            <a:avLst/>
-          </a:prstGeom>
-          <a:solidFill>
-            <a:srgbClr val="D04A02"/>
-          </a:solidFill>
-          <a:ln>
-            <a:noFill/>
-          </a:ln>
-          <a:effectLst/>
-        </p:spPr>
-        <p:style>
-          <a:lnRef idx="1">
-            <a:schemeClr val="accent1"/>
-          </a:lnRef>
-          <a:fillRef idx="3">
-            <a:schemeClr val="accent1"/>
-          </a:fillRef>
-          <a:effectRef idx="2">
-            <a:schemeClr val="accent1"/>
-          </a:effectRef>
-          <a:fontRef idx="minor">
-            <a:schemeClr val="lt1"/>
-          </a:fontRef>
-        </p:style>
-        <p:txBody>
-          <a:bodyPr rtlCol="0" anchor="ctr"/>
-          <a:lstStyle/>
-          <a:p>
-            <a:pPr algn="ctr"/>
-          </a:p>
-        </p:txBody>
-      </p:sp>
-      <p:sp>
-        <p:nvSpPr>
-          <p:cNvPr id="45" name="Right Arrow 44"/>
-          <p:cNvSpPr/>
-          <p:nvPr/>
-        </p:nvSpPr>
-        <p:spPr>
-          <a:xfrm>
-            <a:off x="11332463" y="1248704"/>
-            <a:ext cx="414771" cy="99852"/>
-          </a:xfrm>
-          <a:prstGeom prst="rightArrow">
-            <a:avLst/>
-          </a:prstGeom>
-          <a:solidFill>
-            <a:srgbClr val="D04A02"/>
-          </a:solidFill>
-          <a:ln>
-            <a:noFill/>
-          </a:ln>
-          <a:effectLst/>
-        </p:spPr>
-        <p:style>
-          <a:lnRef idx="1">
-            <a:schemeClr val="accent1"/>
-          </a:lnRef>
-          <a:fillRef idx="3">
-            <a:schemeClr val="accent1"/>
-          </a:fillRef>
-          <a:effectRef idx="2">
-            <a:schemeClr val="accent1"/>
-          </a:effectRef>
-          <a:fontRef idx="minor">
-            <a:schemeClr val="lt1"/>
-          </a:fontRef>
-        </p:style>
-        <p:txBody>
-          <a:bodyPr rtlCol="0" anchor="ctr"/>
-          <a:lstStyle/>
-          <a:p>
-            <a:pPr algn="ctr"/>
-          </a:p>
-        </p:txBody>
-      </p:sp>
-      <p:sp>
-        <p:nvSpPr>
-          <p:cNvPr id="46" name="TextBox 45"/>
+        </p:spPr>
+      </p:pic>
+      <p:sp>
+        <p:nvSpPr>
+          <p:cNvPr id="25" name="TextBox 24"/>
           <p:cNvSpPr txBox="1"/>
           <p:nvPr/>
         </p:nvSpPr>
         <p:spPr>
           <a:xfrm>
-            <a:off x="8262111" y="950976"/>
-            <a:ext cx="3070351" cy="475488"/>
+            <a:off x="8564880" y="950976"/>
+            <a:ext cx="2746247" cy="438912"/>
           </a:xfrm>
           <a:prstGeom prst="rect">
             <a:avLst/>
@@ -5128,7 +4102,7 @@
           <a:noFill/>
         </p:spPr>
         <p:txBody>
-          <a:bodyPr wrap="square" lIns="0" rIns="0" tIns="0" bIns="0"/>
+          <a:bodyPr wrap="square" lIns="18288" rIns="18288" tIns="0" bIns="0"/>
           <a:lstStyle/>
           <a:p>
             <a:pPr algn="l">
@@ -5155,14 +4129,14 @@
       </p:sp>
       <p:sp>
         <p:nvSpPr>
-          <p:cNvPr id="47" name="TextBox 46"/>
+          <p:cNvPr id="26" name="TextBox 25"/>
           <p:cNvSpPr txBox="1"/>
           <p:nvPr/>
         </p:nvSpPr>
         <p:spPr>
           <a:xfrm>
-            <a:off x="8225535" y="1444752"/>
-            <a:ext cx="3564127" cy="566928"/>
+            <a:off x="8235696" y="1444752"/>
+            <a:ext cx="3477767" cy="841247"/>
           </a:xfrm>
           <a:prstGeom prst="rect">
             <a:avLst/>
@@ -5170,12 +4144,15 @@
           <a:noFill/>
         </p:spPr>
         <p:txBody>
-          <a:bodyPr wrap="square" lIns="36576" rIns="36576" tIns="18288" bIns="18288">
+          <a:bodyPr wrap="square" lIns="18288" rIns="18288" tIns="0" bIns="0">
             <a:spAutoFit/>
           </a:bodyPr>
           <a:lstStyle/>
           <a:p>
             <a:pPr algn="l">
+              <a:lnSpc>
+                <a:spcPct val="110000"/>
+              </a:lnSpc>
               <a:spcBef>
                 <a:spcPts val="0"/>
               </a:spcBef>
@@ -5184,7 +4161,7 @@
               </a:spcAft>
             </a:pPr>
             <a:r>
-              <a:rPr sz="1100" b="0" i="0">
+              <a:rPr sz="1200" b="0" i="0">
                 <a:solidFill>
                   <a:srgbClr val="4A4A4A"/>
                 </a:solidFill>
@@ -5199,14 +4176,58 @@
       </p:sp>
       <p:sp>
         <p:nvSpPr>
-          <p:cNvPr id="48" name="TextBox 47"/>
+          <p:cNvPr id="27" name="Rectangle 26"/>
+          <p:cNvSpPr/>
+          <p:nvPr/>
+        </p:nvSpPr>
+        <p:spPr>
+          <a:xfrm>
+            <a:off x="8235696" y="2267712"/>
+            <a:ext cx="256032" cy="32004"/>
+          </a:xfrm>
+          <a:prstGeom prst="rect">
+            <a:avLst/>
+          </a:prstGeom>
+          <a:solidFill>
+            <a:srgbClr val="D04A02"/>
+          </a:solidFill>
+          <a:ln>
+            <a:noFill/>
+          </a:ln>
+          <a:effectLst/>
+        </p:spPr>
+        <p:style>
+          <a:lnRef idx="1">
+            <a:schemeClr val="accent1"/>
+          </a:lnRef>
+          <a:fillRef idx="3">
+            <a:schemeClr val="accent1"/>
+          </a:fillRef>
+          <a:effectRef idx="2">
+            <a:schemeClr val="accent1"/>
+          </a:effectRef>
+          <a:fontRef idx="minor">
+            <a:schemeClr val="lt1"/>
+          </a:fontRef>
+        </p:style>
+        <p:txBody>
+          <a:bodyPr rtlCol="0" anchor="ctr"/>
+          <a:lstStyle/>
+          <a:p>
+            <a:pPr algn="ctr"/>
+          </a:p>
+        </p:txBody>
+      </p:sp>
+      <p:sp>
+        <p:nvSpPr>
+          <p:cNvPr id="28" name="TextBox 27"/>
           <p:cNvSpPr txBox="1"/>
           <p:nvPr/>
         </p:nvSpPr>
         <p:spPr>
           <a:xfrm>
-            <a:off x="8262111" y="2249424"/>
-            <a:ext cx="3490975" cy="201168"/>
+            <a:off x="8235696" y="2340864"/>
+            <a:ext cx="3477767" cy="182880"/>
           </a:xfrm>
           <a:prstGeom prst="rect">
             <a:avLst/>
@@ -5241,14 +4262,14 @@
       </p:sp>
       <p:sp>
         <p:nvSpPr>
-          <p:cNvPr id="49" name="TextBox 48"/>
+          <p:cNvPr id="29" name="TextBox 28"/>
           <p:cNvSpPr txBox="1"/>
           <p:nvPr/>
         </p:nvSpPr>
         <p:spPr>
           <a:xfrm>
-            <a:off x="8262111" y="2432304"/>
-            <a:ext cx="3490975" cy="347472"/>
+            <a:off x="8235696" y="2523744"/>
+            <a:ext cx="3477767" cy="274320"/>
           </a:xfrm>
           <a:prstGeom prst="rect">
             <a:avLst/>
@@ -5268,9 +4289,9 @@
               </a:spcAft>
             </a:pPr>
             <a:r>
-              <a:rPr sz="900" b="0" i="0">
+              <a:rPr sz="1000" b="0" i="0">
                 <a:solidFill>
-                  <a:srgbClr val="6B6B6B"/>
+                  <a:srgbClr val="6F6F6F"/>
                 </a:solidFill>
                 <a:latin typeface="Calibri"/>
                 <a:ea typeface="Calibri"/>
@@ -5283,20 +4304,22 @@
       </p:sp>
       <p:sp>
         <p:nvSpPr>
-          <p:cNvPr id="50" name="Oval 49"/>
+          <p:cNvPr id="30" name="Rounded Rectangle 29"/>
           <p:cNvSpPr/>
           <p:nvPr/>
         </p:nvSpPr>
         <p:spPr>
           <a:xfrm>
-            <a:off x="8044484" y="715060"/>
-            <a:ext cx="307238" cy="307238"/>
-          </a:xfrm>
-          <a:prstGeom prst="ellipse">
-            <a:avLst/>
+            <a:off x="347472" y="2980944"/>
+            <a:ext cx="11494007" cy="2395728"/>
+          </a:xfrm>
+          <a:prstGeom prst="roundRect">
+            <a:avLst>
+              <a:gd name="adj" fmla="val 4000"/>
+            </a:avLst>
           </a:prstGeom>
           <a:solidFill>
-            <a:srgbClr val="FFFFFF"/>
+            <a:srgbClr val="F6F6F6"/>
           </a:solidFill>
           <a:ln>
             <a:noFill/>
@@ -5327,58 +4350,14 @@
       </p:sp>
       <p:sp>
         <p:nvSpPr>
-          <p:cNvPr id="51" name="Oval 50"/>
-          <p:cNvSpPr/>
-          <p:nvPr/>
-        </p:nvSpPr>
-        <p:spPr>
-          <a:xfrm>
-            <a:off x="8060943" y="731520"/>
-            <a:ext cx="274320" cy="274320"/>
-          </a:xfrm>
-          <a:prstGeom prst="ellipse">
-            <a:avLst/>
-          </a:prstGeom>
-          <a:solidFill>
-            <a:srgbClr val="D04A02"/>
-          </a:solidFill>
-          <a:ln>
-            <a:noFill/>
-          </a:ln>
-          <a:effectLst/>
-        </p:spPr>
-        <p:style>
-          <a:lnRef idx="1">
-            <a:schemeClr val="accent1"/>
-          </a:lnRef>
-          <a:fillRef idx="3">
-            <a:schemeClr val="accent1"/>
-          </a:fillRef>
-          <a:effectRef idx="2">
-            <a:schemeClr val="accent1"/>
-          </a:effectRef>
-          <a:fontRef idx="minor">
-            <a:schemeClr val="lt1"/>
-          </a:fontRef>
-        </p:style>
-        <p:txBody>
-          <a:bodyPr rtlCol="0" anchor="ctr"/>
-          <a:lstStyle/>
-          <a:p>
-            <a:pPr algn="ctr"/>
-          </a:p>
-        </p:txBody>
-      </p:sp>
-      <p:sp>
-        <p:nvSpPr>
-          <p:cNvPr id="52" name="TextBox 51"/>
+          <p:cNvPr id="31" name="TextBox 30"/>
           <p:cNvSpPr txBox="1"/>
           <p:nvPr/>
         </p:nvSpPr>
         <p:spPr>
           <a:xfrm>
-            <a:off x="8060943" y="736092"/>
-            <a:ext cx="274320" cy="265176"/>
+            <a:off x="347472" y="3035808"/>
+            <a:ext cx="11494007" cy="201168"/>
           </a:xfrm>
           <a:prstGeom prst="rect">
             <a:avLst/>
@@ -5398,37 +4377,265 @@
               </a:spcAft>
             </a:pPr>
             <a:r>
-              <a:rPr sz="1200" b="1" i="0">
+              <a:rPr sz="1000" b="1" i="0">
                 <a:solidFill>
-                  <a:srgbClr val="FFFFFF"/>
+                  <a:srgbClr val="5A5A5A"/>
                 </a:solidFill>
                 <a:latin typeface="Calibri"/>
                 <a:ea typeface="Calibri"/>
                 <a:cs typeface="Calibri"/>
               </a:rPr>
-              <a:t>3</a:t>
-            </a:r>
-          </a:p>
-        </p:txBody>
-      </p:sp>
-      <p:sp>
-        <p:nvSpPr>
-          <p:cNvPr id="53" name="TextBox 52"/>
-          <p:cNvSpPr txBox="1"/>
-          <p:nvPr/>
-        </p:nvSpPr>
-        <p:spPr>
-          <a:xfrm>
-            <a:off x="292608" y="2907792"/>
-            <a:ext cx="11606783" cy="201168"/>
+              <a:t>HIGH-LEVEL ROADMAP</a:t>
+            </a:r>
+          </a:p>
+        </p:txBody>
+      </p:sp>
+      <p:pic>
+        <p:nvPicPr>
+          <p:cNvPr id="32" name="Picture 31" descr="clipboard.png"/>
+          <p:cNvPicPr>
+            <a:picLocks noChangeAspect="1"/>
+          </p:cNvPicPr>
+          <p:nvPr/>
+        </p:nvPicPr>
+        <p:blipFill>
+          <a:blip r:embed="rId2"/>
+          <a:stretch>
+            <a:fillRect/>
+          </a:stretch>
+        </p:blipFill>
+        <p:spPr>
+          <a:xfrm>
+            <a:off x="493776" y="3401568"/>
+            <a:ext cx="274320" cy="274320"/>
           </a:xfrm>
           <a:prstGeom prst="rect">
             <a:avLst/>
           </a:prstGeom>
+          <a:ln>
+            <a:noFill/>
+          </a:ln>
+        </p:spPr>
+      </p:pic>
+      <p:sp>
+        <p:nvSpPr>
+          <p:cNvPr id="33" name="TextBox 32"/>
+          <p:cNvSpPr txBox="1"/>
+          <p:nvPr/>
+        </p:nvSpPr>
+        <p:spPr>
+          <a:xfrm>
+            <a:off x="822960" y="3346703"/>
+            <a:ext cx="1554480" cy="457200"/>
+          </a:xfrm>
+          <a:prstGeom prst="rect">
+            <a:avLst/>
+          </a:prstGeom>
           <a:noFill/>
         </p:spPr>
         <p:txBody>
           <a:bodyPr wrap="square" lIns="0" rIns="0" tIns="0" bIns="0"/>
+          <a:lstStyle/>
+          <a:p>
+            <a:pPr algn="l">
+              <a:spcBef>
+                <a:spcPts val="0"/>
+              </a:spcBef>
+              <a:spcAft>
+                <a:spcPts val="0"/>
+              </a:spcAft>
+            </a:pPr>
+            <a:r>
+              <a:rPr sz="800" b="1" i="0">
+                <a:solidFill>
+                  <a:srgbClr val="5A5A5A"/>
+                </a:solidFill>
+                <a:latin typeface="Calibri"/>
+                <a:ea typeface="Calibri"/>
+                <a:cs typeface="Calibri"/>
+              </a:rPr>
+              <a:t>BUSINESS REQUIREMENTS &amp;</a:t>
+            </a:r>
+          </a:p>
+          <a:p>
+            <a:pPr algn="l">
+              <a:spcBef>
+                <a:spcPts val="0"/>
+              </a:spcBef>
+              <a:spcAft>
+                <a:spcPts val="0"/>
+              </a:spcAft>
+            </a:pPr>
+            <a:r>
+              <a:rPr sz="800" b="1" i="0">
+                <a:solidFill>
+                  <a:srgbClr val="5A5A5A"/>
+                </a:solidFill>
+                <a:latin typeface="Calibri"/>
+                <a:ea typeface="Calibri"/>
+                <a:cs typeface="Calibri"/>
+              </a:rPr>
+              <a:t>SCALE-UP PLAN</a:t>
+            </a:r>
+          </a:p>
+        </p:txBody>
+      </p:sp>
+      <p:sp>
+        <p:nvSpPr>
+          <p:cNvPr id="34" name="Oval 33"/>
+          <p:cNvSpPr/>
+          <p:nvPr/>
+        </p:nvSpPr>
+        <p:spPr>
+          <a:xfrm>
+            <a:off x="2560320" y="3538727"/>
+            <a:ext cx="128016" cy="128016"/>
+          </a:xfrm>
+          <a:prstGeom prst="ellipse">
+            <a:avLst/>
+          </a:prstGeom>
+          <a:solidFill>
+            <a:srgbClr val="D04A02"/>
+          </a:solidFill>
+          <a:ln>
+            <a:noFill/>
+          </a:ln>
+          <a:effectLst/>
+        </p:spPr>
+        <p:style>
+          <a:lnRef idx="1">
+            <a:schemeClr val="accent1"/>
+          </a:lnRef>
+          <a:fillRef idx="3">
+            <a:schemeClr val="accent1"/>
+          </a:fillRef>
+          <a:effectRef idx="2">
+            <a:schemeClr val="accent1"/>
+          </a:effectRef>
+          <a:fontRef idx="minor">
+            <a:schemeClr val="lt1"/>
+          </a:fontRef>
+        </p:style>
+        <p:txBody>
+          <a:bodyPr rtlCol="0" anchor="ctr"/>
+          <a:lstStyle/>
+          <a:p>
+            <a:pPr algn="ctr"/>
+          </a:p>
+        </p:txBody>
+      </p:sp>
+      <p:sp>
+        <p:nvSpPr>
+          <p:cNvPr id="35" name="Rounded Rectangle 34"/>
+          <p:cNvSpPr/>
+          <p:nvPr/>
+        </p:nvSpPr>
+        <p:spPr>
+          <a:xfrm>
+            <a:off x="2688336" y="3588105"/>
+            <a:ext cx="237743" cy="29260"/>
+          </a:xfrm>
+          <a:prstGeom prst="roundRect">
+            <a:avLst>
+              <a:gd name="adj" fmla="val 50000"/>
+            </a:avLst>
+          </a:prstGeom>
+          <a:solidFill>
+            <a:srgbClr val="D04A02"/>
+          </a:solidFill>
+          <a:ln>
+            <a:noFill/>
+          </a:ln>
+          <a:effectLst/>
+        </p:spPr>
+        <p:style>
+          <a:lnRef idx="1">
+            <a:schemeClr val="accent1"/>
+          </a:lnRef>
+          <a:fillRef idx="3">
+            <a:schemeClr val="accent1"/>
+          </a:fillRef>
+          <a:effectRef idx="2">
+            <a:schemeClr val="accent1"/>
+          </a:effectRef>
+          <a:fontRef idx="minor">
+            <a:schemeClr val="lt1"/>
+          </a:fontRef>
+        </p:style>
+        <p:txBody>
+          <a:bodyPr rtlCol="0" anchor="ctr"/>
+          <a:lstStyle/>
+          <a:p>
+            <a:pPr algn="ctr"/>
+          </a:p>
+        </p:txBody>
+      </p:sp>
+      <p:sp>
+        <p:nvSpPr>
+          <p:cNvPr id="36" name="Rounded Rectangle 35"/>
+          <p:cNvSpPr/>
+          <p:nvPr/>
+        </p:nvSpPr>
+        <p:spPr>
+          <a:xfrm>
+            <a:off x="2926079" y="3346703"/>
+            <a:ext cx="2788920" cy="512064"/>
+          </a:xfrm>
+          <a:prstGeom prst="roundRect">
+            <a:avLst>
+              <a:gd name="adj" fmla="val 12000"/>
+            </a:avLst>
+          </a:prstGeom>
+          <a:solidFill>
+            <a:srgbClr val="FBE6D8"/>
+          </a:solidFill>
+          <a:ln w="12700">
+            <a:solidFill>
+              <a:srgbClr val="D04A02"/>
+            </a:solidFill>
+          </a:ln>
+          <a:effectLst/>
+        </p:spPr>
+        <p:style>
+          <a:lnRef idx="1">
+            <a:schemeClr val="accent1"/>
+          </a:lnRef>
+          <a:fillRef idx="3">
+            <a:schemeClr val="accent1"/>
+          </a:fillRef>
+          <a:effectRef idx="2">
+            <a:schemeClr val="accent1"/>
+          </a:effectRef>
+          <a:fontRef idx="minor">
+            <a:schemeClr val="lt1"/>
+          </a:fontRef>
+        </p:style>
+        <p:txBody>
+          <a:bodyPr rtlCol="0" anchor="ctr"/>
+          <a:lstStyle/>
+          <a:p>
+            <a:pPr algn="ctr"/>
+          </a:p>
+        </p:txBody>
+      </p:sp>
+      <p:sp>
+        <p:nvSpPr>
+          <p:cNvPr id="37" name="TextBox 36"/>
+          <p:cNvSpPr txBox="1"/>
+          <p:nvPr/>
+        </p:nvSpPr>
+        <p:spPr>
+          <a:xfrm>
+            <a:off x="2999232" y="3364991"/>
+            <a:ext cx="2642615" cy="475488"/>
+          </a:xfrm>
+          <a:prstGeom prst="rect">
+            <a:avLst/>
+          </a:prstGeom>
+          <a:noFill/>
+        </p:spPr>
+        <p:txBody>
+          <a:bodyPr wrap="square" lIns="36576" rIns="36576" tIns="18288" bIns="18288"/>
           <a:lstStyle/>
           <a:p>
             <a:pPr algn="ctr">
@@ -5440,33 +4647,33 @@
               </a:spcAft>
             </a:pPr>
             <a:r>
-              <a:rPr sz="1000" b="1" i="0">
+              <a:rPr sz="900" b="0" i="0">
                 <a:solidFill>
-                  <a:srgbClr val="5C5C5C"/>
+                  <a:srgbClr val="2B2B2B"/>
                 </a:solidFill>
                 <a:latin typeface="Calibri"/>
                 <a:ea typeface="Calibri"/>
                 <a:cs typeface="Calibri"/>
               </a:rPr>
-              <a:t>HIGH-LEVEL ROADMAP</a:t>
-            </a:r>
-          </a:p>
-        </p:txBody>
-      </p:sp>
-      <p:sp>
-        <p:nvSpPr>
-          <p:cNvPr id="54" name="Rounded Rectangle 53"/>
+              <a:t>Temporarily pause detailed BRs for other planning capabilities (focus on labeling)</a:t>
+            </a:r>
+          </a:p>
+        </p:txBody>
+      </p:sp>
+      <p:sp>
+        <p:nvSpPr>
+          <p:cNvPr id="38" name="Rounded Rectangle 37"/>
           <p:cNvSpPr/>
           <p:nvPr/>
         </p:nvSpPr>
         <p:spPr>
           <a:xfrm>
-            <a:off x="327720" y="3302081"/>
-            <a:ext cx="222382" cy="239938"/>
+            <a:off x="5751576" y="3588105"/>
+            <a:ext cx="64008" cy="29260"/>
           </a:xfrm>
           <a:prstGeom prst="roundRect">
             <a:avLst>
-              <a:gd name="adj" fmla="val 12000"/>
+              <a:gd name="adj" fmla="val 50000"/>
             </a:avLst>
           </a:prstGeom>
           <a:solidFill>
@@ -5501,18 +4708,18 @@
       </p:sp>
       <p:sp>
         <p:nvSpPr>
-          <p:cNvPr id="55" name="Rounded Rectangle 54"/>
+          <p:cNvPr id="39" name="Rounded Rectangle 38"/>
           <p:cNvSpPr/>
           <p:nvPr/>
         </p:nvSpPr>
         <p:spPr>
           <a:xfrm>
-            <a:off x="386242" y="3261116"/>
-            <a:ext cx="105338" cy="64373"/>
+            <a:off x="5861304" y="3588105"/>
+            <a:ext cx="64008" cy="29260"/>
           </a:xfrm>
           <a:prstGeom prst="roundRect">
             <a:avLst>
-              <a:gd name="adj" fmla="val 30000"/>
+              <a:gd name="adj" fmla="val 50000"/>
             </a:avLst>
           </a:prstGeom>
           <a:solidFill>
@@ -5547,22 +4754,22 @@
       </p:sp>
       <p:sp>
         <p:nvSpPr>
-          <p:cNvPr id="56" name="Rounded Rectangle 55"/>
+          <p:cNvPr id="40" name="Rounded Rectangle 39"/>
           <p:cNvSpPr/>
           <p:nvPr/>
         </p:nvSpPr>
         <p:spPr>
           <a:xfrm>
-            <a:off x="403799" y="3272820"/>
-            <a:ext cx="70225" cy="35112"/>
+            <a:off x="5971032" y="3588105"/>
+            <a:ext cx="64008" cy="29260"/>
           </a:xfrm>
           <a:prstGeom prst="roundRect">
             <a:avLst>
-              <a:gd name="adj" fmla="val 30000"/>
+              <a:gd name="adj" fmla="val 50000"/>
             </a:avLst>
           </a:prstGeom>
           <a:solidFill>
-            <a:srgbClr val="FFFFFF"/>
+            <a:srgbClr val="D04A02"/>
           </a:solidFill>
           <a:ln>
             <a:noFill/>
@@ -5593,22 +4800,22 @@
       </p:sp>
       <p:sp>
         <p:nvSpPr>
-          <p:cNvPr id="57" name="Rounded Rectangle 56"/>
+          <p:cNvPr id="41" name="Rounded Rectangle 40"/>
           <p:cNvSpPr/>
           <p:nvPr/>
         </p:nvSpPr>
         <p:spPr>
           <a:xfrm>
-            <a:off x="368686" y="3366455"/>
-            <a:ext cx="29260" cy="29260"/>
+            <a:off x="6080760" y="3588105"/>
+            <a:ext cx="64008" cy="29260"/>
           </a:xfrm>
           <a:prstGeom prst="roundRect">
             <a:avLst>
-              <a:gd name="adj" fmla="val 40000"/>
+              <a:gd name="adj" fmla="val 50000"/>
             </a:avLst>
           </a:prstGeom>
           <a:solidFill>
-            <a:srgbClr val="FFFFFF"/>
+            <a:srgbClr val="D04A02"/>
           </a:solidFill>
           <a:ln>
             <a:noFill/>
@@ -5639,14 +4846,14 @@
       </p:sp>
       <p:sp>
         <p:nvSpPr>
-          <p:cNvPr id="58" name="Rounded Rectangle 57"/>
+          <p:cNvPr id="42" name="Rounded Rectangle 41"/>
           <p:cNvSpPr/>
           <p:nvPr/>
         </p:nvSpPr>
         <p:spPr>
           <a:xfrm>
-            <a:off x="415503" y="3372307"/>
-            <a:ext cx="99486" cy="17556"/>
+            <a:off x="6190488" y="3588105"/>
+            <a:ext cx="64008" cy="29260"/>
           </a:xfrm>
           <a:prstGeom prst="roundRect">
             <a:avLst>
@@ -5654,7 +4861,7 @@
             </a:avLst>
           </a:prstGeom>
           <a:solidFill>
-            <a:srgbClr val="FFFFFF"/>
+            <a:srgbClr val="D04A02"/>
           </a:solidFill>
           <a:ln>
             <a:noFill/>
@@ -5685,22 +4892,22 @@
       </p:sp>
       <p:sp>
         <p:nvSpPr>
-          <p:cNvPr id="59" name="Rounded Rectangle 58"/>
+          <p:cNvPr id="43" name="Rounded Rectangle 42"/>
           <p:cNvSpPr/>
           <p:nvPr/>
         </p:nvSpPr>
         <p:spPr>
           <a:xfrm>
-            <a:off x="368686" y="3413272"/>
-            <a:ext cx="29260" cy="29260"/>
+            <a:off x="6318504" y="3588105"/>
+            <a:ext cx="2148839" cy="29260"/>
           </a:xfrm>
           <a:prstGeom prst="roundRect">
             <a:avLst>
-              <a:gd name="adj" fmla="val 40000"/>
+              <a:gd name="adj" fmla="val 50000"/>
             </a:avLst>
           </a:prstGeom>
           <a:solidFill>
-            <a:srgbClr val="FFFFFF"/>
+            <a:srgbClr val="D04A02"/>
           </a:solidFill>
           <a:ln>
             <a:noFill/>
@@ -5731,22 +4938,23 @@
       </p:sp>
       <p:sp>
         <p:nvSpPr>
-          <p:cNvPr id="60" name="Rounded Rectangle 59"/>
+          <p:cNvPr id="44" name="Right Arrow 43"/>
           <p:cNvSpPr/>
           <p:nvPr/>
         </p:nvSpPr>
         <p:spPr>
           <a:xfrm>
-            <a:off x="415503" y="3419124"/>
-            <a:ext cx="99486" cy="17556"/>
-          </a:xfrm>
-          <a:prstGeom prst="roundRect">
+            <a:off x="8449056" y="3547871"/>
+            <a:ext cx="137160" cy="109728"/>
+          </a:xfrm>
+          <a:prstGeom prst="rightArrow">
             <a:avLst>
-              <a:gd name="adj" fmla="val 50000"/>
+              <a:gd name="adj1" fmla="val 50000"/>
+              <a:gd name="adj2" fmla="val 50000"/>
             </a:avLst>
           </a:prstGeom>
           <a:solidFill>
-            <a:srgbClr val="FFFFFF"/>
+            <a:srgbClr val="D04A02"/>
           </a:solidFill>
           <a:ln>
             <a:noFill/>
@@ -5777,106 +4985,14 @@
       </p:sp>
       <p:sp>
         <p:nvSpPr>
-          <p:cNvPr id="61" name="Rounded Rectangle 60"/>
-          <p:cNvSpPr/>
-          <p:nvPr/>
-        </p:nvSpPr>
-        <p:spPr>
-          <a:xfrm>
-            <a:off x="368686" y="3460089"/>
-            <a:ext cx="29260" cy="29260"/>
-          </a:xfrm>
-          <a:prstGeom prst="roundRect">
-            <a:avLst>
-              <a:gd name="adj" fmla="val 40000"/>
-            </a:avLst>
-          </a:prstGeom>
-          <a:solidFill>
-            <a:srgbClr val="FFFFFF"/>
-          </a:solidFill>
-          <a:ln>
-            <a:noFill/>
-          </a:ln>
-          <a:effectLst/>
-        </p:spPr>
-        <p:style>
-          <a:lnRef idx="1">
-            <a:schemeClr val="accent1"/>
-          </a:lnRef>
-          <a:fillRef idx="3">
-            <a:schemeClr val="accent1"/>
-          </a:fillRef>
-          <a:effectRef idx="2">
-            <a:schemeClr val="accent1"/>
-          </a:effectRef>
-          <a:fontRef idx="minor">
-            <a:schemeClr val="lt1"/>
-          </a:fontRef>
-        </p:style>
-        <p:txBody>
-          <a:bodyPr rtlCol="0" anchor="ctr"/>
-          <a:lstStyle/>
-          <a:p>
-            <a:pPr algn="ctr"/>
-          </a:p>
-        </p:txBody>
-      </p:sp>
-      <p:sp>
-        <p:nvSpPr>
-          <p:cNvPr id="62" name="Rounded Rectangle 61"/>
-          <p:cNvSpPr/>
-          <p:nvPr/>
-        </p:nvSpPr>
-        <p:spPr>
-          <a:xfrm>
-            <a:off x="415503" y="3465941"/>
-            <a:ext cx="99486" cy="17556"/>
-          </a:xfrm>
-          <a:prstGeom prst="roundRect">
-            <a:avLst>
-              <a:gd name="adj" fmla="val 50000"/>
-            </a:avLst>
-          </a:prstGeom>
-          <a:solidFill>
-            <a:srgbClr val="FFFFFF"/>
-          </a:solidFill>
-          <a:ln>
-            <a:noFill/>
-          </a:ln>
-          <a:effectLst/>
-        </p:spPr>
-        <p:style>
-          <a:lnRef idx="1">
-            <a:schemeClr val="accent1"/>
-          </a:lnRef>
-          <a:fillRef idx="3">
-            <a:schemeClr val="accent1"/>
-          </a:fillRef>
-          <a:effectRef idx="2">
-            <a:schemeClr val="accent1"/>
-          </a:effectRef>
-          <a:fontRef idx="minor">
-            <a:schemeClr val="lt1"/>
-          </a:fontRef>
-        </p:style>
-        <p:txBody>
-          <a:bodyPr rtlCol="0" anchor="ctr"/>
-          <a:lstStyle/>
-          <a:p>
-            <a:pPr algn="ctr"/>
-          </a:p>
-        </p:txBody>
-      </p:sp>
-      <p:sp>
-        <p:nvSpPr>
-          <p:cNvPr id="63" name="TextBox 62"/>
+          <p:cNvPr id="45" name="TextBox 44"/>
           <p:cNvSpPr txBox="1"/>
           <p:nvPr/>
         </p:nvSpPr>
         <p:spPr>
           <a:xfrm>
-            <a:off x="640080" y="3182112"/>
-            <a:ext cx="1554480" cy="493776"/>
+            <a:off x="8613648" y="3346703"/>
+            <a:ext cx="3063239" cy="512064"/>
           </a:xfrm>
           <a:prstGeom prst="rect">
             <a:avLst/>
@@ -5884,7 +5000,7 @@
           <a:noFill/>
         </p:spPr>
         <p:txBody>
-          <a:bodyPr wrap="square" lIns="0" rIns="0" tIns="0" bIns="0"/>
+          <a:bodyPr wrap="square" lIns="18288" rIns="18288" tIns="18288" bIns="18288"/>
           <a:lstStyle/>
           <a:p>
             <a:pPr algn="l">
@@ -5896,17 +5012,65 @@
               </a:spcAft>
             </a:pPr>
             <a:r>
-              <a:rPr sz="800" b="1" i="0">
+              <a:rPr sz="900" b="0" i="0">
                 <a:solidFill>
-                  <a:srgbClr val="5C5C5C"/>
+                  <a:srgbClr val="4A4A4A"/>
                 </a:solidFill>
                 <a:latin typeface="Calibri"/>
                 <a:ea typeface="Calibri"/>
                 <a:cs typeface="Calibri"/>
               </a:rPr>
-              <a:t>BUSINESS REQUIREMENTS &amp;</a:t>
-            </a:r>
-          </a:p>
+              <a:t>Complete remaining BRs and prioritize future releases</a:t>
+            </a:r>
+          </a:p>
+        </p:txBody>
+      </p:sp>
+      <p:pic>
+        <p:nvPicPr>
+          <p:cNvPr id="46" name="Picture 45" descr="hex_gray.png"/>
+          <p:cNvPicPr>
+            <a:picLocks noChangeAspect="1"/>
+          </p:cNvPicPr>
+          <p:nvPr/>
+        </p:nvPicPr>
+        <p:blipFill>
+          <a:blip r:embed="rId6"/>
+          <a:stretch>
+            <a:fillRect/>
+          </a:stretch>
+        </p:blipFill>
+        <p:spPr>
+          <a:xfrm>
+            <a:off x="493776" y="4096511"/>
+            <a:ext cx="274320" cy="274320"/>
+          </a:xfrm>
+          <a:prstGeom prst="rect">
+            <a:avLst/>
+          </a:prstGeom>
+          <a:ln>
+            <a:noFill/>
+          </a:ln>
+        </p:spPr>
+      </p:pic>
+      <p:sp>
+        <p:nvSpPr>
+          <p:cNvPr id="47" name="TextBox 46"/>
+          <p:cNvSpPr txBox="1"/>
+          <p:nvPr/>
+        </p:nvSpPr>
+        <p:spPr>
+          <a:xfrm>
+            <a:off x="822960" y="4059935"/>
+            <a:ext cx="1554480" cy="420624"/>
+          </a:xfrm>
+          <a:prstGeom prst="rect">
+            <a:avLst/>
+          </a:prstGeom>
+          <a:noFill/>
+        </p:spPr>
+        <p:txBody>
+          <a:bodyPr wrap="square" lIns="0" rIns="0" tIns="0" bIns="0"/>
+          <a:lstStyle/>
           <a:p>
             <a:pPr algn="l">
               <a:spcBef>
@@ -5919,33 +5083,54 @@
             <a:r>
               <a:rPr sz="800" b="1" i="0">
                 <a:solidFill>
-                  <a:srgbClr val="5C5C5C"/>
+                  <a:srgbClr val="5A5A5A"/>
                 </a:solidFill>
                 <a:latin typeface="Calibri"/>
                 <a:ea typeface="Calibri"/>
                 <a:cs typeface="Calibri"/>
               </a:rPr>
-              <a:t>SCALE-UP PLAN</a:t>
-            </a:r>
-          </a:p>
-        </p:txBody>
-      </p:sp>
-      <p:sp>
-        <p:nvSpPr>
-          <p:cNvPr id="64" name="Oval 63"/>
+              <a:t>MVP DEFINITION</a:t>
+            </a:r>
+          </a:p>
+          <a:p>
+            <a:pPr algn="l">
+              <a:spcBef>
+                <a:spcPts val="0"/>
+              </a:spcBef>
+              <a:spcAft>
+                <a:spcPts val="0"/>
+              </a:spcAft>
+            </a:pPr>
+            <a:r>
+              <a:rPr sz="800" b="1" i="0">
+                <a:solidFill>
+                  <a:srgbClr val="5A5A5A"/>
+                </a:solidFill>
+                <a:latin typeface="Calibri"/>
+                <a:ea typeface="Calibri"/>
+                <a:cs typeface="Calibri"/>
+              </a:rPr>
+              <a:t>&amp; DECISION</a:t>
+            </a:r>
+          </a:p>
+        </p:txBody>
+      </p:sp>
+      <p:sp>
+        <p:nvSpPr>
+          <p:cNvPr id="48" name="Oval 47"/>
           <p:cNvSpPr/>
           <p:nvPr/>
         </p:nvSpPr>
         <p:spPr>
           <a:xfrm>
-            <a:off x="2377439" y="3378708"/>
-            <a:ext cx="155448" cy="155448"/>
+            <a:off x="2569463" y="4224528"/>
+            <a:ext cx="109728" cy="109728"/>
           </a:xfrm>
           <a:prstGeom prst="ellipse">
             <a:avLst/>
           </a:prstGeom>
           <a:solidFill>
-            <a:srgbClr val="D04A02"/>
+            <a:srgbClr val="C8C8C8"/>
           </a:solidFill>
           <a:ln>
             <a:noFill/>
@@ -5974,64 +5159,27 @@
           </a:p>
         </p:txBody>
       </p:sp>
-      <p:cxnSp>
-        <p:nvCxnSpPr>
-          <p:cNvPr id="65" name="Connector 64"/>
-          <p:cNvCxnSpPr/>
-          <p:nvPr/>
-        </p:nvCxnSpPr>
-        <p:spPr>
-          <a:xfrm>
-            <a:off x="2532887" y="3456432"/>
-            <a:ext cx="283464" cy="0"/>
-          </a:xfrm>
-          <a:prstGeom prst="line">
-            <a:avLst/>
-          </a:prstGeom>
-          <a:ln w="31750">
-            <a:solidFill>
-              <a:srgbClr val="D04A02"/>
-            </a:solidFill>
-          </a:ln>
-        </p:spPr>
-        <p:style>
-          <a:lnRef idx="2">
-            <a:schemeClr val="accent1"/>
-          </a:lnRef>
-          <a:fillRef idx="0">
-            <a:schemeClr val="accent1"/>
-          </a:fillRef>
-          <a:effectRef idx="1">
-            <a:schemeClr val="accent1"/>
-          </a:effectRef>
-          <a:fontRef idx="minor">
-            <a:schemeClr val="tx1"/>
-          </a:fontRef>
-        </p:style>
-      </p:cxnSp>
-      <p:sp>
-        <p:nvSpPr>
-          <p:cNvPr id="66" name="Rounded Rectangle 65"/>
+      <p:sp>
+        <p:nvSpPr>
+          <p:cNvPr id="49" name="Rounded Rectangle 48"/>
           <p:cNvSpPr/>
           <p:nvPr/>
         </p:nvSpPr>
         <p:spPr>
           <a:xfrm>
-            <a:off x="2816351" y="3200400"/>
-            <a:ext cx="2606040" cy="512064"/>
+            <a:off x="2679191" y="4267504"/>
+            <a:ext cx="246888" cy="23774"/>
           </a:xfrm>
           <a:prstGeom prst="roundRect">
             <a:avLst>
-              <a:gd name="adj" fmla="val 10000"/>
+              <a:gd name="adj" fmla="val 50000"/>
             </a:avLst>
           </a:prstGeom>
           <a:solidFill>
-            <a:srgbClr val="FBE8DC"/>
+            <a:srgbClr val="C8C8C8"/>
           </a:solidFill>
-          <a:ln w="14604">
-            <a:solidFill>
-              <a:srgbClr val="D04A02"/>
-            </a:solidFill>
+          <a:ln>
+            <a:noFill/>
           </a:ln>
           <a:effectLst/>
         </p:spPr>
@@ -6059,14 +5207,62 @@
       </p:sp>
       <p:sp>
         <p:nvSpPr>
-          <p:cNvPr id="67" name="TextBox 66"/>
+          <p:cNvPr id="50" name="Rounded Rectangle 49"/>
+          <p:cNvSpPr/>
+          <p:nvPr/>
+        </p:nvSpPr>
+        <p:spPr>
+          <a:xfrm>
+            <a:off x="2926079" y="4041648"/>
+            <a:ext cx="2788920" cy="475488"/>
+          </a:xfrm>
+          <a:prstGeom prst="roundRect">
+            <a:avLst>
+              <a:gd name="adj" fmla="val 12000"/>
+            </a:avLst>
+          </a:prstGeom>
+          <a:solidFill>
+            <a:srgbClr val="FFFFFF"/>
+          </a:solidFill>
+          <a:ln w="12700">
+            <a:solidFill>
+              <a:srgbClr val="C8C8C8"/>
+            </a:solidFill>
+          </a:ln>
+          <a:effectLst/>
+        </p:spPr>
+        <p:style>
+          <a:lnRef idx="1">
+            <a:schemeClr val="accent1"/>
+          </a:lnRef>
+          <a:fillRef idx="3">
+            <a:schemeClr val="accent1"/>
+          </a:fillRef>
+          <a:effectRef idx="2">
+            <a:schemeClr val="accent1"/>
+          </a:effectRef>
+          <a:fontRef idx="minor">
+            <a:schemeClr val="lt1"/>
+          </a:fontRef>
+        </p:style>
+        <p:txBody>
+          <a:bodyPr rtlCol="0" anchor="ctr"/>
+          <a:lstStyle/>
+          <a:p>
+            <a:pPr algn="ctr"/>
+          </a:p>
+        </p:txBody>
+      </p:sp>
+      <p:sp>
+        <p:nvSpPr>
+          <p:cNvPr id="51" name="TextBox 50"/>
           <p:cNvSpPr txBox="1"/>
           <p:nvPr/>
         </p:nvSpPr>
         <p:spPr>
           <a:xfrm>
-            <a:off x="2871215" y="3218688"/>
-            <a:ext cx="2496312" cy="475488"/>
+            <a:off x="2999232" y="4059935"/>
+            <a:ext cx="2642615" cy="438912"/>
           </a:xfrm>
           <a:prstGeom prst="rect">
             <a:avLst/>
@@ -6086,487 +5282,9 @@
               </a:spcAft>
             </a:pPr>
             <a:r>
-              <a:rPr sz="800" b="0" i="0">
+              <a:rPr sz="1100" b="1" i="0">
                 <a:solidFill>
-                  <a:srgbClr val="1A1A1A"/>
-                </a:solidFill>
-                <a:latin typeface="Calibri"/>
-                <a:ea typeface="Calibri"/>
-                <a:cs typeface="Calibri"/>
-              </a:rPr>
-              <a:t>Temporarily pause detailed BRs for other planning capabilities (focus on labeling)</a:t>
-            </a:r>
-          </a:p>
-        </p:txBody>
-      </p:sp>
-      <p:cxnSp>
-        <p:nvCxnSpPr>
-          <p:cNvPr id="68" name="Connector 67"/>
-          <p:cNvCxnSpPr/>
-          <p:nvPr/>
-        </p:nvCxnSpPr>
-        <p:spPr>
-          <a:xfrm>
-            <a:off x="5422392" y="3456432"/>
-            <a:ext cx="667511" cy="0"/>
-          </a:xfrm>
-          <a:prstGeom prst="line">
-            <a:avLst/>
-          </a:prstGeom>
-          <a:ln w="31750">
-            <a:solidFill>
-              <a:srgbClr val="D04A02"/>
-            </a:solidFill>
-            <a:prstDash val="dash"/>
-          </a:ln>
-        </p:spPr>
-        <p:style>
-          <a:lnRef idx="2">
-            <a:schemeClr val="accent1"/>
-          </a:lnRef>
-          <a:fillRef idx="0">
-            <a:schemeClr val="accent1"/>
-          </a:fillRef>
-          <a:effectRef idx="1">
-            <a:schemeClr val="accent1"/>
-          </a:effectRef>
-          <a:fontRef idx="minor">
-            <a:schemeClr val="tx1"/>
-          </a:fontRef>
-        </p:style>
-      </p:cxnSp>
-      <p:cxnSp>
-        <p:nvCxnSpPr>
-          <p:cNvPr id="69" name="Connector 68"/>
-          <p:cNvCxnSpPr/>
-          <p:nvPr/>
-        </p:nvCxnSpPr>
-        <p:spPr>
-          <a:xfrm>
-            <a:off x="6089903" y="3456432"/>
-            <a:ext cx="2331721" cy="0"/>
-          </a:xfrm>
-          <a:prstGeom prst="line">
-            <a:avLst/>
-          </a:prstGeom>
-          <a:ln w="31750">
-            <a:solidFill>
-              <a:srgbClr val="D04A02"/>
-            </a:solidFill>
-            <a:tailEnd type="triangle" w="med" len="med"/>
-          </a:ln>
-        </p:spPr>
-        <p:style>
-          <a:lnRef idx="2">
-            <a:schemeClr val="accent1"/>
-          </a:lnRef>
-          <a:fillRef idx="0">
-            <a:schemeClr val="accent1"/>
-          </a:fillRef>
-          <a:effectRef idx="1">
-            <a:schemeClr val="accent1"/>
-          </a:effectRef>
-          <a:fontRef idx="minor">
-            <a:schemeClr val="tx1"/>
-          </a:fontRef>
-        </p:style>
-      </p:cxnSp>
-      <p:sp>
-        <p:nvSpPr>
-          <p:cNvPr id="70" name="TextBox 69"/>
-          <p:cNvSpPr txBox="1"/>
-          <p:nvPr/>
-        </p:nvSpPr>
-        <p:spPr>
-          <a:xfrm>
-            <a:off x="8494776" y="3200400"/>
-            <a:ext cx="3404615" cy="512064"/>
-          </a:xfrm>
-          <a:prstGeom prst="rect">
-            <a:avLst/>
-          </a:prstGeom>
-          <a:noFill/>
-        </p:spPr>
-        <p:txBody>
-          <a:bodyPr wrap="square" lIns="18288" rIns="18288" tIns="18288" bIns="18288"/>
-          <a:lstStyle/>
-          <a:p>
-            <a:pPr algn="l">
-              <a:spcBef>
-                <a:spcPts val="0"/>
-              </a:spcBef>
-              <a:spcAft>
-                <a:spcPts val="0"/>
-              </a:spcAft>
-            </a:pPr>
-            <a:r>
-              <a:rPr sz="800" b="0" i="0">
-                <a:solidFill>
-                  <a:srgbClr val="4A4A4A"/>
-                </a:solidFill>
-                <a:latin typeface="Calibri"/>
-                <a:ea typeface="Calibri"/>
-                <a:cs typeface="Calibri"/>
-              </a:rPr>
-              <a:t>Complete remaining BRs and prioritize future releases</a:t>
-            </a:r>
-          </a:p>
-        </p:txBody>
-      </p:sp>
-      <p:sp>
-        <p:nvSpPr>
-          <p:cNvPr id="71" name="Hexagon 70"/>
-          <p:cNvSpPr/>
-          <p:nvPr/>
-        </p:nvSpPr>
-        <p:spPr>
-          <a:xfrm>
-            <a:off x="292608" y="4005072"/>
-            <a:ext cx="292608" cy="269199"/>
-          </a:xfrm>
-          <a:prstGeom prst="hexagon">
-            <a:avLst/>
-          </a:prstGeom>
-          <a:solidFill>
-            <a:srgbClr val="6B6B6B"/>
-          </a:solidFill>
-          <a:ln>
-            <a:noFill/>
-          </a:ln>
-          <a:effectLst/>
-        </p:spPr>
-        <p:style>
-          <a:lnRef idx="1">
-            <a:schemeClr val="accent1"/>
-          </a:lnRef>
-          <a:fillRef idx="3">
-            <a:schemeClr val="accent1"/>
-          </a:fillRef>
-          <a:effectRef idx="2">
-            <a:schemeClr val="accent1"/>
-          </a:effectRef>
-          <a:fontRef idx="minor">
-            <a:schemeClr val="lt1"/>
-          </a:fontRef>
-        </p:style>
-        <p:txBody>
-          <a:bodyPr rtlCol="0" anchor="ctr"/>
-          <a:lstStyle/>
-          <a:p>
-            <a:pPr algn="ctr"/>
-          </a:p>
-        </p:txBody>
-      </p:sp>
-      <p:sp>
-        <p:nvSpPr>
-          <p:cNvPr id="72" name="Hexagon 71"/>
-          <p:cNvSpPr/>
-          <p:nvPr/>
-        </p:nvSpPr>
-        <p:spPr>
-          <a:xfrm>
-            <a:off x="356981" y="4063008"/>
-            <a:ext cx="163860" cy="153326"/>
-          </a:xfrm>
-          <a:prstGeom prst="hexagon">
-            <a:avLst/>
-          </a:prstGeom>
-          <a:solidFill>
-            <a:srgbClr val="FFFFFF"/>
-          </a:solidFill>
-          <a:ln>
-            <a:noFill/>
-          </a:ln>
-          <a:effectLst/>
-        </p:spPr>
-        <p:style>
-          <a:lnRef idx="1">
-            <a:schemeClr val="accent1"/>
-          </a:lnRef>
-          <a:fillRef idx="3">
-            <a:schemeClr val="accent1"/>
-          </a:fillRef>
-          <a:effectRef idx="2">
-            <a:schemeClr val="accent1"/>
-          </a:effectRef>
-          <a:fontRef idx="minor">
-            <a:schemeClr val="lt1"/>
-          </a:fontRef>
-        </p:style>
-        <p:txBody>
-          <a:bodyPr rtlCol="0" anchor="ctr"/>
-          <a:lstStyle/>
-          <a:p>
-            <a:pPr algn="ctr"/>
-          </a:p>
-        </p:txBody>
-      </p:sp>
-      <p:sp>
-        <p:nvSpPr>
-          <p:cNvPr id="73" name="Oval 72"/>
-          <p:cNvSpPr/>
-          <p:nvPr/>
-        </p:nvSpPr>
-        <p:spPr>
-          <a:xfrm>
-            <a:off x="397946" y="4094610"/>
-            <a:ext cx="81930" cy="81930"/>
-          </a:xfrm>
-          <a:prstGeom prst="ellipse">
-            <a:avLst/>
-          </a:prstGeom>
-          <a:solidFill>
-            <a:srgbClr val="6B6B6B"/>
-          </a:solidFill>
-          <a:ln>
-            <a:noFill/>
-          </a:ln>
-          <a:effectLst/>
-        </p:spPr>
-        <p:style>
-          <a:lnRef idx="1">
-            <a:schemeClr val="accent1"/>
-          </a:lnRef>
-          <a:fillRef idx="3">
-            <a:schemeClr val="accent1"/>
-          </a:fillRef>
-          <a:effectRef idx="2">
-            <a:schemeClr val="accent1"/>
-          </a:effectRef>
-          <a:fontRef idx="minor">
-            <a:schemeClr val="lt1"/>
-          </a:fontRef>
-        </p:style>
-        <p:txBody>
-          <a:bodyPr rtlCol="0" anchor="ctr"/>
-          <a:lstStyle/>
-          <a:p>
-            <a:pPr algn="ctr"/>
-          </a:p>
-        </p:txBody>
-      </p:sp>
-      <p:sp>
-        <p:nvSpPr>
-          <p:cNvPr id="74" name="TextBox 73"/>
-          <p:cNvSpPr txBox="1"/>
-          <p:nvPr/>
-        </p:nvSpPr>
-        <p:spPr>
-          <a:xfrm>
-            <a:off x="640080" y="3968496"/>
-            <a:ext cx="1554480" cy="457200"/>
-          </a:xfrm>
-          <a:prstGeom prst="rect">
-            <a:avLst/>
-          </a:prstGeom>
-          <a:noFill/>
-        </p:spPr>
-        <p:txBody>
-          <a:bodyPr wrap="square" lIns="0" rIns="0" tIns="0" bIns="0"/>
-          <a:lstStyle/>
-          <a:p>
-            <a:pPr algn="l">
-              <a:spcBef>
-                <a:spcPts val="0"/>
-              </a:spcBef>
-              <a:spcAft>
-                <a:spcPts val="0"/>
-              </a:spcAft>
-            </a:pPr>
-            <a:r>
-              <a:rPr sz="800" b="1" i="0">
-                <a:solidFill>
-                  <a:srgbClr val="5C5C5C"/>
-                </a:solidFill>
-                <a:latin typeface="Calibri"/>
-                <a:ea typeface="Calibri"/>
-                <a:cs typeface="Calibri"/>
-              </a:rPr>
-              <a:t>MVP DEFINITION</a:t>
-            </a:r>
-          </a:p>
-          <a:p>
-            <a:pPr algn="l">
-              <a:spcBef>
-                <a:spcPts val="0"/>
-              </a:spcBef>
-              <a:spcAft>
-                <a:spcPts val="0"/>
-              </a:spcAft>
-            </a:pPr>
-            <a:r>
-              <a:rPr sz="800" b="1" i="0">
-                <a:solidFill>
-                  <a:srgbClr val="5C5C5C"/>
-                </a:solidFill>
-                <a:latin typeface="Calibri"/>
-                <a:ea typeface="Calibri"/>
-                <a:cs typeface="Calibri"/>
-              </a:rPr>
-              <a:t>&amp; DECISION</a:t>
-            </a:r>
-          </a:p>
-        </p:txBody>
-      </p:sp>
-      <p:sp>
-        <p:nvSpPr>
-          <p:cNvPr id="75" name="Oval 74"/>
-          <p:cNvSpPr/>
-          <p:nvPr/>
-        </p:nvSpPr>
-        <p:spPr>
-          <a:xfrm>
-            <a:off x="2395727" y="4133088"/>
-            <a:ext cx="109728" cy="109728"/>
-          </a:xfrm>
-          <a:prstGeom prst="ellipse">
-            <a:avLst/>
-          </a:prstGeom>
-          <a:solidFill>
-            <a:srgbClr val="B0B0B0"/>
-          </a:solidFill>
-          <a:ln>
-            <a:noFill/>
-          </a:ln>
-          <a:effectLst/>
-        </p:spPr>
-        <p:style>
-          <a:lnRef idx="1">
-            <a:schemeClr val="accent1"/>
-          </a:lnRef>
-          <a:fillRef idx="3">
-            <a:schemeClr val="accent1"/>
-          </a:fillRef>
-          <a:effectRef idx="2">
-            <a:schemeClr val="accent1"/>
-          </a:effectRef>
-          <a:fontRef idx="minor">
-            <a:schemeClr val="lt1"/>
-          </a:fontRef>
-        </p:style>
-        <p:txBody>
-          <a:bodyPr rtlCol="0" anchor="ctr"/>
-          <a:lstStyle/>
-          <a:p>
-            <a:pPr algn="ctr"/>
-          </a:p>
-        </p:txBody>
-      </p:sp>
-      <p:cxnSp>
-        <p:nvCxnSpPr>
-          <p:cNvPr id="76" name="Connector 75"/>
-          <p:cNvCxnSpPr/>
-          <p:nvPr/>
-        </p:nvCxnSpPr>
-        <p:spPr>
-          <a:xfrm>
-            <a:off x="2505456" y="4187952"/>
-            <a:ext cx="310895" cy="0"/>
-          </a:xfrm>
-          <a:prstGeom prst="line">
-            <a:avLst/>
-          </a:prstGeom>
-          <a:ln w="23495">
-            <a:solidFill>
-              <a:srgbClr val="B0B0B0"/>
-            </a:solidFill>
-          </a:ln>
-        </p:spPr>
-        <p:style>
-          <a:lnRef idx="2">
-            <a:schemeClr val="accent1"/>
-          </a:lnRef>
-          <a:fillRef idx="0">
-            <a:schemeClr val="accent1"/>
-          </a:fillRef>
-          <a:effectRef idx="1">
-            <a:schemeClr val="accent1"/>
-          </a:effectRef>
-          <a:fontRef idx="minor">
-            <a:schemeClr val="tx1"/>
-          </a:fontRef>
-        </p:style>
-      </p:cxnSp>
-      <p:sp>
-        <p:nvSpPr>
-          <p:cNvPr id="77" name="Rounded Rectangle 76"/>
-          <p:cNvSpPr/>
-          <p:nvPr/>
-        </p:nvSpPr>
-        <p:spPr>
-          <a:xfrm>
-            <a:off x="2816351" y="3950207"/>
-            <a:ext cx="2606040" cy="475488"/>
-          </a:xfrm>
-          <a:prstGeom prst="roundRect">
-            <a:avLst>
-              <a:gd name="adj" fmla="val 10000"/>
-            </a:avLst>
-          </a:prstGeom>
-          <a:solidFill>
-            <a:srgbClr val="F3F3F3"/>
-          </a:solidFill>
-          <a:ln w="14604">
-            <a:solidFill>
-              <a:srgbClr val="B0B0B0"/>
-            </a:solidFill>
-          </a:ln>
-          <a:effectLst/>
-        </p:spPr>
-        <p:style>
-          <a:lnRef idx="1">
-            <a:schemeClr val="accent1"/>
-          </a:lnRef>
-          <a:fillRef idx="3">
-            <a:schemeClr val="accent1"/>
-          </a:fillRef>
-          <a:effectRef idx="2">
-            <a:schemeClr val="accent1"/>
-          </a:effectRef>
-          <a:fontRef idx="minor">
-            <a:schemeClr val="lt1"/>
-          </a:fontRef>
-        </p:style>
-        <p:txBody>
-          <a:bodyPr rtlCol="0" anchor="ctr"/>
-          <a:lstStyle/>
-          <a:p>
-            <a:pPr algn="ctr"/>
-          </a:p>
-        </p:txBody>
-      </p:sp>
-      <p:sp>
-        <p:nvSpPr>
-          <p:cNvPr id="78" name="TextBox 77"/>
-          <p:cNvSpPr txBox="1"/>
-          <p:nvPr/>
-        </p:nvSpPr>
-        <p:spPr>
-          <a:xfrm>
-            <a:off x="2871215" y="3968496"/>
-            <a:ext cx="2496312" cy="438912"/>
-          </a:xfrm>
-          <a:prstGeom prst="rect">
-            <a:avLst/>
-          </a:prstGeom>
-          <a:noFill/>
-        </p:spPr>
-        <p:txBody>
-          <a:bodyPr wrap="square" lIns="36576" rIns="36576" tIns="18288" bIns="18288"/>
-          <a:lstStyle/>
-          <a:p>
-            <a:pPr algn="ctr">
-              <a:spcBef>
-                <a:spcPts val="0"/>
-              </a:spcBef>
-              <a:spcAft>
-                <a:spcPts val="0"/>
-              </a:spcAft>
-            </a:pPr>
-            <a:r>
-              <a:rPr sz="1000" b="1" i="0">
-                <a:solidFill>
-                  <a:srgbClr val="1A1A1A"/>
+                  <a:srgbClr val="2B2B2B"/>
                 </a:solidFill>
                 <a:latin typeface="Calibri"/>
                 <a:ea typeface="Calibri"/>
@@ -6577,62 +5295,27 @@
           </a:p>
         </p:txBody>
       </p:sp>
-      <p:cxnSp>
-        <p:nvCxnSpPr>
-          <p:cNvPr id="79" name="Connector 78"/>
-          <p:cNvCxnSpPr/>
-          <p:nvPr/>
-        </p:nvCxnSpPr>
-        <p:spPr>
-          <a:xfrm>
-            <a:off x="5422392" y="4187952"/>
-            <a:ext cx="201167" cy="0"/>
-          </a:xfrm>
-          <a:prstGeom prst="line">
-            <a:avLst/>
-          </a:prstGeom>
-          <a:ln w="23495">
-            <a:solidFill>
-              <a:srgbClr val="B0B0B0"/>
-            </a:solidFill>
-          </a:ln>
-        </p:spPr>
-        <p:style>
-          <a:lnRef idx="2">
-            <a:schemeClr val="accent1"/>
-          </a:lnRef>
-          <a:fillRef idx="0">
-            <a:schemeClr val="accent1"/>
-          </a:fillRef>
-          <a:effectRef idx="1">
-            <a:schemeClr val="accent1"/>
-          </a:effectRef>
-          <a:fontRef idx="minor">
-            <a:schemeClr val="tx1"/>
-          </a:fontRef>
-        </p:style>
-      </p:cxnSp>
-      <p:sp>
-        <p:nvSpPr>
-          <p:cNvPr id="80" name="Oval 79"/>
+      <p:sp>
+        <p:nvSpPr>
+          <p:cNvPr id="52" name="Rounded Rectangle 51"/>
           <p:cNvSpPr/>
           <p:nvPr/>
         </p:nvSpPr>
         <p:spPr>
           <a:xfrm>
-            <a:off x="5586983" y="4005072"/>
-            <a:ext cx="347472" cy="347472"/>
-          </a:xfrm>
-          <a:prstGeom prst="ellipse">
-            <a:avLst/>
+            <a:off x="5751576" y="4267504"/>
+            <a:ext cx="146304" cy="23774"/>
+          </a:xfrm>
+          <a:prstGeom prst="roundRect">
+            <a:avLst>
+              <a:gd name="adj" fmla="val 50000"/>
+            </a:avLst>
           </a:prstGeom>
           <a:solidFill>
-            <a:srgbClr val="FFFFFF"/>
+            <a:srgbClr val="C8C8C8"/>
           </a:solidFill>
-          <a:ln w="19050">
-            <a:solidFill>
-              <a:srgbClr val="6B6B6B"/>
-            </a:solidFill>
+          <a:ln>
+            <a:noFill/>
           </a:ln>
           <a:effectLst/>
         </p:spPr>
@@ -6658,60 +5341,43 @@
           </a:p>
         </p:txBody>
       </p:sp>
-      <p:sp>
-        <p:nvSpPr>
-          <p:cNvPr id="81" name="5-Point Star 80"/>
-          <p:cNvSpPr/>
-          <p:nvPr/>
-        </p:nvSpPr>
-        <p:spPr>
-          <a:xfrm>
-            <a:off x="5649528" y="4067616"/>
-            <a:ext cx="222382" cy="222382"/>
-          </a:xfrm>
-          <a:prstGeom prst="star5">
+      <p:pic>
+        <p:nvPicPr>
+          <p:cNvPr id="53" name="Picture 52" descr="star.png"/>
+          <p:cNvPicPr>
+            <a:picLocks noChangeAspect="1"/>
+          </p:cNvPicPr>
+          <p:nvPr/>
+        </p:nvPicPr>
+        <p:blipFill>
+          <a:blip r:embed="rId7"/>
+          <a:stretch>
+            <a:fillRect/>
+          </a:stretch>
+        </p:blipFill>
+        <p:spPr>
+          <a:xfrm>
+            <a:off x="5861304" y="4078224"/>
+            <a:ext cx="347472" cy="347472"/>
+          </a:xfrm>
+          <a:prstGeom prst="rect">
             <a:avLst/>
           </a:prstGeom>
-          <a:solidFill>
-            <a:srgbClr val="6B6B6B"/>
-          </a:solidFill>
           <a:ln>
             <a:noFill/>
           </a:ln>
-          <a:effectLst/>
-        </p:spPr>
-        <p:style>
-          <a:lnRef idx="1">
-            <a:schemeClr val="accent1"/>
-          </a:lnRef>
-          <a:fillRef idx="3">
-            <a:schemeClr val="accent1"/>
-          </a:fillRef>
-          <a:effectRef idx="2">
-            <a:schemeClr val="accent1"/>
-          </a:effectRef>
-          <a:fontRef idx="minor">
-            <a:schemeClr val="lt1"/>
-          </a:fontRef>
-        </p:style>
-        <p:txBody>
-          <a:bodyPr rtlCol="0" anchor="ctr"/>
-          <a:lstStyle/>
-          <a:p>
-            <a:pPr algn="ctr"/>
-          </a:p>
-        </p:txBody>
-      </p:sp>
-      <p:sp>
-        <p:nvSpPr>
-          <p:cNvPr id="82" name="TextBox 81"/>
+        </p:spPr>
+      </p:pic>
+      <p:sp>
+        <p:nvSpPr>
+          <p:cNvPr id="54" name="TextBox 53"/>
           <p:cNvSpPr txBox="1"/>
           <p:nvPr/>
         </p:nvSpPr>
         <p:spPr>
           <a:xfrm>
-            <a:off x="5385816" y="4352544"/>
-            <a:ext cx="749808" cy="182880"/>
+            <a:off x="5696712" y="4425696"/>
+            <a:ext cx="694944" cy="164592"/>
           </a:xfrm>
           <a:prstGeom prst="rect">
             <a:avLst/>
@@ -6744,58 +5410,24 @@
           </a:p>
         </p:txBody>
       </p:sp>
-      <p:cxnSp>
-        <p:nvCxnSpPr>
-          <p:cNvPr id="83" name="Connector 82"/>
-          <p:cNvCxnSpPr/>
-          <p:nvPr/>
-        </p:nvCxnSpPr>
-        <p:spPr>
-          <a:xfrm>
-            <a:off x="5760720" y="4352544"/>
-            <a:ext cx="0" cy="420624"/>
-          </a:xfrm>
-          <a:prstGeom prst="line">
-            <a:avLst/>
-          </a:prstGeom>
-          <a:ln w="17145">
-            <a:solidFill>
-              <a:srgbClr val="B0B0B0"/>
-            </a:solidFill>
-            <a:prstDash val="dash"/>
-          </a:ln>
-        </p:spPr>
-        <p:style>
-          <a:lnRef idx="2">
-            <a:schemeClr val="accent1"/>
-          </a:lnRef>
-          <a:fillRef idx="0">
-            <a:schemeClr val="accent1"/>
-          </a:fillRef>
-          <a:effectRef idx="1">
-            <a:schemeClr val="accent1"/>
-          </a:effectRef>
-          <a:fontRef idx="minor">
-            <a:schemeClr val="tx1"/>
-          </a:fontRef>
-        </p:style>
-      </p:cxnSp>
-      <p:sp>
-        <p:nvSpPr>
-          <p:cNvPr id="84" name="Cube 83"/>
+      <p:sp>
+        <p:nvSpPr>
+          <p:cNvPr id="55" name="Rounded Rectangle 54"/>
           <p:cNvSpPr/>
           <p:nvPr/>
         </p:nvSpPr>
         <p:spPr>
           <a:xfrm>
-            <a:off x="292608" y="4736592"/>
-            <a:ext cx="310896" cy="310896"/>
-          </a:xfrm>
-          <a:prstGeom prst="cube">
-            <a:avLst/>
+            <a:off x="6026810" y="4425696"/>
+            <a:ext cx="16459" cy="54864"/>
+          </a:xfrm>
+          <a:prstGeom prst="roundRect">
+            <a:avLst>
+              <a:gd name="adj" fmla="val 50000"/>
+            </a:avLst>
           </a:prstGeom>
           <a:solidFill>
-            <a:srgbClr val="D04A02"/>
+            <a:srgbClr val="C8C8C8"/>
           </a:solidFill>
           <a:ln>
             <a:noFill/>
@@ -6826,14 +5458,225 @@
       </p:sp>
       <p:sp>
         <p:nvSpPr>
-          <p:cNvPr id="85" name="TextBox 84"/>
+          <p:cNvPr id="56" name="Rounded Rectangle 55"/>
+          <p:cNvSpPr/>
+          <p:nvPr/>
+        </p:nvSpPr>
+        <p:spPr>
+          <a:xfrm>
+            <a:off x="6026810" y="4521708"/>
+            <a:ext cx="16459" cy="54864"/>
+          </a:xfrm>
+          <a:prstGeom prst="roundRect">
+            <a:avLst>
+              <a:gd name="adj" fmla="val 50000"/>
+            </a:avLst>
+          </a:prstGeom>
+          <a:solidFill>
+            <a:srgbClr val="C8C8C8"/>
+          </a:solidFill>
+          <a:ln>
+            <a:noFill/>
+          </a:ln>
+          <a:effectLst/>
+        </p:spPr>
+        <p:style>
+          <a:lnRef idx="1">
+            <a:schemeClr val="accent1"/>
+          </a:lnRef>
+          <a:fillRef idx="3">
+            <a:schemeClr val="accent1"/>
+          </a:fillRef>
+          <a:effectRef idx="2">
+            <a:schemeClr val="accent1"/>
+          </a:effectRef>
+          <a:fontRef idx="minor">
+            <a:schemeClr val="lt1"/>
+          </a:fontRef>
+        </p:style>
+        <p:txBody>
+          <a:bodyPr rtlCol="0" anchor="ctr"/>
+          <a:lstStyle/>
+          <a:p>
+            <a:pPr algn="ctr"/>
+          </a:p>
+        </p:txBody>
+      </p:sp>
+      <p:sp>
+        <p:nvSpPr>
+          <p:cNvPr id="57" name="Rounded Rectangle 56"/>
+          <p:cNvSpPr/>
+          <p:nvPr/>
+        </p:nvSpPr>
+        <p:spPr>
+          <a:xfrm>
+            <a:off x="6026810" y="4617720"/>
+            <a:ext cx="16459" cy="54864"/>
+          </a:xfrm>
+          <a:prstGeom prst="roundRect">
+            <a:avLst>
+              <a:gd name="adj" fmla="val 50000"/>
+            </a:avLst>
+          </a:prstGeom>
+          <a:solidFill>
+            <a:srgbClr val="C8C8C8"/>
+          </a:solidFill>
+          <a:ln>
+            <a:noFill/>
+          </a:ln>
+          <a:effectLst/>
+        </p:spPr>
+        <p:style>
+          <a:lnRef idx="1">
+            <a:schemeClr val="accent1"/>
+          </a:lnRef>
+          <a:fillRef idx="3">
+            <a:schemeClr val="accent1"/>
+          </a:fillRef>
+          <a:effectRef idx="2">
+            <a:schemeClr val="accent1"/>
+          </a:effectRef>
+          <a:fontRef idx="minor">
+            <a:schemeClr val="lt1"/>
+          </a:fontRef>
+        </p:style>
+        <p:txBody>
+          <a:bodyPr rtlCol="0" anchor="ctr"/>
+          <a:lstStyle/>
+          <a:p>
+            <a:pPr algn="ctr"/>
+          </a:p>
+        </p:txBody>
+      </p:sp>
+      <p:sp>
+        <p:nvSpPr>
+          <p:cNvPr id="58" name="Rounded Rectangle 57"/>
+          <p:cNvSpPr/>
+          <p:nvPr/>
+        </p:nvSpPr>
+        <p:spPr>
+          <a:xfrm>
+            <a:off x="6026810" y="4713732"/>
+            <a:ext cx="16459" cy="54864"/>
+          </a:xfrm>
+          <a:prstGeom prst="roundRect">
+            <a:avLst>
+              <a:gd name="adj" fmla="val 50000"/>
+            </a:avLst>
+          </a:prstGeom>
+          <a:solidFill>
+            <a:srgbClr val="C8C8C8"/>
+          </a:solidFill>
+          <a:ln>
+            <a:noFill/>
+          </a:ln>
+          <a:effectLst/>
+        </p:spPr>
+        <p:style>
+          <a:lnRef idx="1">
+            <a:schemeClr val="accent1"/>
+          </a:lnRef>
+          <a:fillRef idx="3">
+            <a:schemeClr val="accent1"/>
+          </a:fillRef>
+          <a:effectRef idx="2">
+            <a:schemeClr val="accent1"/>
+          </a:effectRef>
+          <a:fontRef idx="minor">
+            <a:schemeClr val="lt1"/>
+          </a:fontRef>
+        </p:style>
+        <p:txBody>
+          <a:bodyPr rtlCol="0" anchor="ctr"/>
+          <a:lstStyle/>
+          <a:p>
+            <a:pPr algn="ctr"/>
+          </a:p>
+        </p:txBody>
+      </p:sp>
+      <p:sp>
+        <p:nvSpPr>
+          <p:cNvPr id="59" name="Rounded Rectangle 58"/>
+          <p:cNvSpPr/>
+          <p:nvPr/>
+        </p:nvSpPr>
+        <p:spPr>
+          <a:xfrm>
+            <a:off x="6026810" y="4809744"/>
+            <a:ext cx="16459" cy="54864"/>
+          </a:xfrm>
+          <a:prstGeom prst="roundRect">
+            <a:avLst>
+              <a:gd name="adj" fmla="val 50000"/>
+            </a:avLst>
+          </a:prstGeom>
+          <a:solidFill>
+            <a:srgbClr val="C8C8C8"/>
+          </a:solidFill>
+          <a:ln>
+            <a:noFill/>
+          </a:ln>
+          <a:effectLst/>
+        </p:spPr>
+        <p:style>
+          <a:lnRef idx="1">
+            <a:schemeClr val="accent1"/>
+          </a:lnRef>
+          <a:fillRef idx="3">
+            <a:schemeClr val="accent1"/>
+          </a:fillRef>
+          <a:effectRef idx="2">
+            <a:schemeClr val="accent1"/>
+          </a:effectRef>
+          <a:fontRef idx="minor">
+            <a:schemeClr val="lt1"/>
+          </a:fontRef>
+        </p:style>
+        <p:txBody>
+          <a:bodyPr rtlCol="0" anchor="ctr"/>
+          <a:lstStyle/>
+          <a:p>
+            <a:pPr algn="ctr"/>
+          </a:p>
+        </p:txBody>
+      </p:sp>
+      <p:pic>
+        <p:nvPicPr>
+          <p:cNvPr id="60" name="Picture 59" descr="cube.png"/>
+          <p:cNvPicPr>
+            <a:picLocks noChangeAspect="1"/>
+          </p:cNvPicPr>
+          <p:nvPr/>
+        </p:nvPicPr>
+        <p:blipFill>
+          <a:blip r:embed="rId8"/>
+          <a:stretch>
+            <a:fillRect/>
+          </a:stretch>
+        </p:blipFill>
+        <p:spPr>
+          <a:xfrm>
+            <a:off x="493776" y="4809744"/>
+            <a:ext cx="274320" cy="274320"/>
+          </a:xfrm>
+          <a:prstGeom prst="rect">
+            <a:avLst/>
+          </a:prstGeom>
+          <a:ln>
+            <a:noFill/>
+          </a:ln>
+        </p:spPr>
+      </p:pic>
+      <p:sp>
+        <p:nvSpPr>
+          <p:cNvPr id="61" name="TextBox 60"/>
           <p:cNvSpPr txBox="1"/>
           <p:nvPr/>
         </p:nvSpPr>
         <p:spPr>
           <a:xfrm>
-            <a:off x="640080" y="4754880"/>
-            <a:ext cx="1554480" cy="329184"/>
+            <a:off x="822960" y="4828032"/>
+            <a:ext cx="1554480" cy="256032"/>
           </a:xfrm>
           <a:prstGeom prst="rect">
             <a:avLst/>
@@ -6855,7 +5698,7 @@
             <a:r>
               <a:rPr sz="800" b="1" i="0">
                 <a:solidFill>
-                  <a:srgbClr val="5C5C5C"/>
+                  <a:srgbClr val="5A5A5A"/>
                 </a:solidFill>
                 <a:latin typeface="Calibri"/>
                 <a:ea typeface="Calibri"/>
@@ -6868,60 +5711,14 @@
       </p:sp>
       <p:sp>
         <p:nvSpPr>
-          <p:cNvPr id="86" name="Rounded Rectangle 85"/>
-          <p:cNvSpPr/>
-          <p:nvPr/>
-        </p:nvSpPr>
-        <p:spPr>
-          <a:xfrm>
-            <a:off x="5660136" y="4846320"/>
-            <a:ext cx="4782312" cy="329184"/>
-          </a:xfrm>
-          <a:prstGeom prst="roundRect">
-            <a:avLst>
-              <a:gd name="adj" fmla="val 35000"/>
-            </a:avLst>
-          </a:prstGeom>
-          <a:solidFill>
-            <a:srgbClr val="F3C4A8"/>
-          </a:solidFill>
-          <a:ln>
-            <a:noFill/>
-          </a:ln>
-          <a:effectLst/>
-        </p:spPr>
-        <p:style>
-          <a:lnRef idx="1">
-            <a:schemeClr val="accent1"/>
-          </a:lnRef>
-          <a:fillRef idx="3">
-            <a:schemeClr val="accent1"/>
-          </a:fillRef>
-          <a:effectRef idx="2">
-            <a:schemeClr val="accent1"/>
-          </a:effectRef>
-          <a:fontRef idx="minor">
-            <a:schemeClr val="lt1"/>
-          </a:fontRef>
-        </p:style>
-        <p:txBody>
-          <a:bodyPr rtlCol="0" anchor="ctr"/>
-          <a:lstStyle/>
-          <a:p>
-            <a:pPr algn="ctr"/>
-          </a:p>
-        </p:txBody>
-      </p:sp>
-      <p:sp>
-        <p:nvSpPr>
-          <p:cNvPr id="87" name="TextBox 86"/>
+          <p:cNvPr id="62" name="TextBox 61"/>
           <p:cNvSpPr txBox="1"/>
           <p:nvPr/>
         </p:nvSpPr>
         <p:spPr>
           <a:xfrm>
-            <a:off x="5660136" y="4846320"/>
-            <a:ext cx="4782312" cy="329184"/>
+            <a:off x="6300216" y="4681728"/>
+            <a:ext cx="5120640" cy="182880"/>
           </a:xfrm>
           <a:prstGeom prst="rect">
             <a:avLst/>
@@ -6929,49 +5726,7 @@
           <a:noFill/>
         </p:spPr>
         <p:txBody>
-          <a:bodyPr wrap="square" lIns="73152" rIns="73152" tIns="0" bIns="0"/>
-          <a:lstStyle/>
-          <a:p>
-            <a:pPr algn="ctr">
-              <a:spcBef>
-                <a:spcPts val="0"/>
-              </a:spcBef>
-              <a:spcAft>
-                <a:spcPts val="0"/>
-              </a:spcAft>
-            </a:pPr>
-            <a:r>
-              <a:rPr sz="1000" b="1" i="0">
-                <a:solidFill>
-                  <a:srgbClr val="1A1A1A"/>
-                </a:solidFill>
-                <a:latin typeface="Calibri"/>
-                <a:ea typeface="Calibri"/>
-                <a:cs typeface="Calibri"/>
-              </a:rPr>
-              <a:t>MVP Build  (duration longer than BRs)</a:t>
-            </a:r>
-          </a:p>
-        </p:txBody>
-      </p:sp>
-      <p:sp>
-        <p:nvSpPr>
-          <p:cNvPr id="88" name="TextBox 87"/>
-          <p:cNvSpPr txBox="1"/>
-          <p:nvPr/>
-        </p:nvSpPr>
-        <p:spPr>
-          <a:xfrm>
-            <a:off x="6163055" y="4590288"/>
-            <a:ext cx="4937760" cy="219456"/>
-          </a:xfrm>
-          <a:prstGeom prst="rect">
-            <a:avLst/>
-          </a:prstGeom>
-          <a:noFill/>
-        </p:spPr>
-        <p:txBody>
-          <a:bodyPr wrap="square" lIns="18288" rIns="0" tIns="0" bIns="0"/>
+          <a:bodyPr wrap="square" lIns="0" rIns="0" tIns="0" bIns="0"/>
           <a:lstStyle/>
           <a:p>
             <a:pPr algn="l">
@@ -6998,20 +5753,22 @@
       </p:sp>
       <p:sp>
         <p:nvSpPr>
-          <p:cNvPr id="89" name="Oval 88"/>
+          <p:cNvPr id="63" name="Rounded Rectangle 62"/>
           <p:cNvSpPr/>
           <p:nvPr/>
         </p:nvSpPr>
         <p:spPr>
           <a:xfrm>
-            <a:off x="10533888" y="4828032"/>
-            <a:ext cx="329184" cy="329184"/>
-          </a:xfrm>
-          <a:prstGeom prst="ellipse">
-            <a:avLst/>
+            <a:off x="5879592" y="4901184"/>
+            <a:ext cx="4315968" cy="310896"/>
+          </a:xfrm>
+          <a:prstGeom prst="roundRect">
+            <a:avLst>
+              <a:gd name="adj" fmla="val 45000"/>
+            </a:avLst>
           </a:prstGeom>
           <a:solidFill>
-            <a:srgbClr val="D04A02"/>
+            <a:srgbClr val="F2C2A3"/>
           </a:solidFill>
           <a:ln>
             <a:noFill/>
@@ -7042,14 +5799,14 @@
       </p:sp>
       <p:sp>
         <p:nvSpPr>
-          <p:cNvPr id="90" name="TextBox 89"/>
+          <p:cNvPr id="64" name="TextBox 63"/>
           <p:cNvSpPr txBox="1"/>
           <p:nvPr/>
         </p:nvSpPr>
         <p:spPr>
           <a:xfrm>
-            <a:off x="10533888" y="4837176"/>
-            <a:ext cx="329184" cy="329184"/>
+            <a:off x="5879592" y="4901184"/>
+            <a:ext cx="4315968" cy="310896"/>
           </a:xfrm>
           <a:prstGeom prst="rect">
             <a:avLst/>
@@ -7057,7 +5814,7 @@
           <a:noFill/>
         </p:spPr>
         <p:txBody>
-          <a:bodyPr wrap="square" lIns="0" rIns="0" tIns="0" bIns="0"/>
+          <a:bodyPr wrap="square" lIns="73152" rIns="73152" tIns="0" bIns="0"/>
           <a:lstStyle/>
           <a:p>
             <a:pPr algn="ctr">
@@ -7069,29 +5826,56 @@
               </a:spcAft>
             </a:pPr>
             <a:r>
-              <a:rPr sz="1200" b="1" i="0">
+              <a:rPr sz="1100" b="1" i="0">
                 <a:solidFill>
-                  <a:srgbClr val="FFFFFF"/>
+                  <a:srgbClr val="2B2B2B"/>
                 </a:solidFill>
                 <a:latin typeface="Calibri"/>
                 <a:ea typeface="Calibri"/>
                 <a:cs typeface="Calibri"/>
               </a:rPr>
-              <a:t>✓</a:t>
-            </a:r>
-          </a:p>
-        </p:txBody>
-      </p:sp>
-      <p:sp>
-        <p:nvSpPr>
-          <p:cNvPr id="91" name="TextBox 90"/>
+              <a:t>MVP Build   (duration longer than BRs)</a:t>
+            </a:r>
+          </a:p>
+        </p:txBody>
+      </p:sp>
+      <p:pic>
+        <p:nvPicPr>
+          <p:cNvPr id="65" name="Picture 64" descr="check.png"/>
+          <p:cNvPicPr>
+            <a:picLocks noChangeAspect="1"/>
+          </p:cNvPicPr>
+          <p:nvPr/>
+        </p:nvPicPr>
+        <p:blipFill>
+          <a:blip r:embed="rId9"/>
+          <a:stretch>
+            <a:fillRect/>
+          </a:stretch>
+        </p:blipFill>
+        <p:spPr>
+          <a:xfrm>
+            <a:off x="10305288" y="4882896"/>
+            <a:ext cx="329184" cy="329184"/>
+          </a:xfrm>
+          <a:prstGeom prst="rect">
+            <a:avLst/>
+          </a:prstGeom>
+          <a:ln>
+            <a:noFill/>
+          </a:ln>
+        </p:spPr>
+      </p:pic>
+      <p:sp>
+        <p:nvSpPr>
+          <p:cNvPr id="66" name="TextBox 65"/>
           <p:cNvSpPr txBox="1"/>
           <p:nvPr/>
         </p:nvSpPr>
         <p:spPr>
           <a:xfrm>
-            <a:off x="10899648" y="4754880"/>
-            <a:ext cx="999743" cy="438912"/>
+            <a:off x="10671048" y="4828032"/>
+            <a:ext cx="1024127" cy="420624"/>
           </a:xfrm>
           <a:prstGeom prst="rect">
             <a:avLst/>
@@ -7111,7 +5895,7 @@
               </a:spcAft>
             </a:pPr>
             <a:r>
-              <a:rPr sz="800" b="1" i="0">
+              <a:rPr sz="900" b="1" i="0">
                 <a:solidFill>
                   <a:srgbClr val="D04A02"/>
                 </a:solidFill>
@@ -7132,7 +5916,7 @@
               </a:spcAft>
             </a:pPr>
             <a:r>
-              <a:rPr sz="800" b="1" i="0">
+              <a:rPr sz="900" b="1" i="0">
                 <a:solidFill>
                   <a:srgbClr val="D04A02"/>
                 </a:solidFill>
@@ -7147,22 +5931,22 @@
       </p:sp>
       <p:sp>
         <p:nvSpPr>
-          <p:cNvPr id="92" name="Rounded Rectangle 91"/>
+          <p:cNvPr id="67" name="Rounded Rectangle 66"/>
           <p:cNvSpPr/>
           <p:nvPr/>
         </p:nvSpPr>
         <p:spPr>
           <a:xfrm>
-            <a:off x="292608" y="5504688"/>
-            <a:ext cx="11606783" cy="713232"/>
+            <a:off x="347472" y="5486400"/>
+            <a:ext cx="11494007" cy="658368"/>
           </a:xfrm>
           <a:prstGeom prst="roundRect">
             <a:avLst>
-              <a:gd name="adj" fmla="val 8000"/>
+              <a:gd name="adj" fmla="val 10000"/>
             </a:avLst>
           </a:prstGeom>
           <a:solidFill>
-            <a:srgbClr val="F3F3F3"/>
+            <a:srgbClr val="F6F6F6"/>
           </a:solidFill>
           <a:ln>
             <a:noFill/>
@@ -7191,148 +5975,43 @@
           </a:p>
         </p:txBody>
       </p:sp>
-      <p:sp>
-        <p:nvSpPr>
-          <p:cNvPr id="93" name="Hexagon 92"/>
-          <p:cNvSpPr/>
-          <p:nvPr/>
-        </p:nvSpPr>
-        <p:spPr>
-          <a:xfrm>
-            <a:off x="457200" y="5687568"/>
-            <a:ext cx="365760" cy="336499"/>
-          </a:xfrm>
-          <a:prstGeom prst="hexagon">
+      <p:pic>
+        <p:nvPicPr>
+          <p:cNvPr id="68" name="Picture 67" descr="hex_orange.png"/>
+          <p:cNvPicPr>
+            <a:picLocks noChangeAspect="1"/>
+          </p:cNvPicPr>
+          <p:nvPr/>
+        </p:nvPicPr>
+        <p:blipFill>
+          <a:blip r:embed="rId10"/>
+          <a:stretch>
+            <a:fillRect/>
+          </a:stretch>
+        </p:blipFill>
+        <p:spPr>
+          <a:xfrm>
+            <a:off x="512064" y="5632704"/>
+            <a:ext cx="365760" cy="365760"/>
+          </a:xfrm>
+          <a:prstGeom prst="rect">
             <a:avLst/>
           </a:prstGeom>
-          <a:solidFill>
-            <a:srgbClr val="D04A02"/>
-          </a:solidFill>
           <a:ln>
             <a:noFill/>
           </a:ln>
-          <a:effectLst/>
-        </p:spPr>
-        <p:style>
-          <a:lnRef idx="1">
-            <a:schemeClr val="accent1"/>
-          </a:lnRef>
-          <a:fillRef idx="3">
-            <a:schemeClr val="accent1"/>
-          </a:fillRef>
-          <a:effectRef idx="2">
-            <a:schemeClr val="accent1"/>
-          </a:effectRef>
-          <a:fontRef idx="minor">
-            <a:schemeClr val="lt1"/>
-          </a:fontRef>
-        </p:style>
-        <p:txBody>
-          <a:bodyPr rtlCol="0" anchor="ctr"/>
-          <a:lstStyle/>
-          <a:p>
-            <a:pPr algn="ctr"/>
-          </a:p>
-        </p:txBody>
-      </p:sp>
-      <p:sp>
-        <p:nvSpPr>
-          <p:cNvPr id="94" name="Hexagon 93"/>
-          <p:cNvSpPr/>
-          <p:nvPr/>
-        </p:nvSpPr>
-        <p:spPr>
-          <a:xfrm>
-            <a:off x="537667" y="5759988"/>
-            <a:ext cx="204825" cy="191658"/>
-          </a:xfrm>
-          <a:prstGeom prst="hexagon">
-            <a:avLst/>
-          </a:prstGeom>
-          <a:solidFill>
-            <a:srgbClr val="FFFFFF"/>
-          </a:solidFill>
-          <a:ln>
-            <a:noFill/>
-          </a:ln>
-          <a:effectLst/>
-        </p:spPr>
-        <p:style>
-          <a:lnRef idx="1">
-            <a:schemeClr val="accent1"/>
-          </a:lnRef>
-          <a:fillRef idx="3">
-            <a:schemeClr val="accent1"/>
-          </a:fillRef>
-          <a:effectRef idx="2">
-            <a:schemeClr val="accent1"/>
-          </a:effectRef>
-          <a:fontRef idx="minor">
-            <a:schemeClr val="lt1"/>
-          </a:fontRef>
-        </p:style>
-        <p:txBody>
-          <a:bodyPr rtlCol="0" anchor="ctr"/>
-          <a:lstStyle/>
-          <a:p>
-            <a:pPr algn="ctr"/>
-          </a:p>
-        </p:txBody>
-      </p:sp>
-      <p:sp>
-        <p:nvSpPr>
-          <p:cNvPr id="95" name="Oval 94"/>
-          <p:cNvSpPr/>
-          <p:nvPr/>
-        </p:nvSpPr>
-        <p:spPr>
-          <a:xfrm>
-            <a:off x="588873" y="5799490"/>
-            <a:ext cx="102412" cy="102412"/>
-          </a:xfrm>
-          <a:prstGeom prst="ellipse">
-            <a:avLst/>
-          </a:prstGeom>
-          <a:solidFill>
-            <a:srgbClr val="D04A02"/>
-          </a:solidFill>
-          <a:ln>
-            <a:noFill/>
-          </a:ln>
-          <a:effectLst/>
-        </p:spPr>
-        <p:style>
-          <a:lnRef idx="1">
-            <a:schemeClr val="accent1"/>
-          </a:lnRef>
-          <a:fillRef idx="3">
-            <a:schemeClr val="accent1"/>
-          </a:fillRef>
-          <a:effectRef idx="2">
-            <a:schemeClr val="accent1"/>
-          </a:effectRef>
-          <a:fontRef idx="minor">
-            <a:schemeClr val="lt1"/>
-          </a:fontRef>
-        </p:style>
-        <p:txBody>
-          <a:bodyPr rtlCol="0" anchor="ctr"/>
-          <a:lstStyle/>
-          <a:p>
-            <a:pPr algn="ctr"/>
-          </a:p>
-        </p:txBody>
-      </p:sp>
-      <p:sp>
-        <p:nvSpPr>
-          <p:cNvPr id="96" name="TextBox 95"/>
+        </p:spPr>
+      </p:pic>
+      <p:sp>
+        <p:nvSpPr>
+          <p:cNvPr id="69" name="TextBox 68"/>
           <p:cNvSpPr txBox="1"/>
           <p:nvPr/>
         </p:nvSpPr>
         <p:spPr>
           <a:xfrm>
-            <a:off x="932688" y="5596127"/>
-            <a:ext cx="10783823" cy="530352"/>
+            <a:off x="969264" y="5559552"/>
+            <a:ext cx="10707624" cy="512064"/>
           </a:xfrm>
           <a:prstGeom prst="rect">
             <a:avLst/>
@@ -7340,7 +6019,7 @@
           <a:noFill/>
         </p:spPr>
         <p:txBody>
-          <a:bodyPr wrap="square" lIns="54864" rIns="73152" tIns="36576" bIns="36576">
+          <a:bodyPr wrap="square" lIns="36576" rIns="73152" tIns="18288" bIns="18288">
             <a:spAutoFit/>
           </a:bodyPr>
           <a:lstStyle/>
@@ -7354,9 +6033,9 @@
               </a:spcAft>
             </a:pPr>
             <a:r>
-              <a:rPr sz="1300" b="1" i="0">
+              <a:rPr sz="1400" b="1" i="0">
                 <a:solidFill>
-                  <a:srgbClr val="1A1A1A"/>
+                  <a:srgbClr val="2B2B2B"/>
                 </a:solidFill>
                 <a:latin typeface="Calibri"/>
                 <a:ea typeface="Calibri"/>
@@ -7365,7 +6044,7 @@
               <a:t>Outcome: </a:t>
             </a:r>
             <a:r>
-              <a:rPr sz="1300" b="0" i="0">
+              <a:rPr sz="1400" b="0" i="0">
                 <a:solidFill>
                   <a:srgbClr val="4A4A4A"/>
                 </a:solidFill>
@@ -7380,13 +6059,13 @@
       </p:sp>
       <p:sp>
         <p:nvSpPr>
-          <p:cNvPr id="97" name="TextBox 96"/>
+          <p:cNvPr id="70" name="TextBox 69"/>
           <p:cNvSpPr txBox="1"/>
           <p:nvPr/>
         </p:nvSpPr>
         <p:spPr>
           <a:xfrm>
-            <a:off x="292608" y="6355080"/>
+            <a:off x="347472" y="6272784"/>
             <a:ext cx="1005840" cy="292608"/>
           </a:xfrm>
           <a:prstGeom prst="rect">
@@ -7422,14 +6101,14 @@
       </p:sp>
       <p:sp>
         <p:nvSpPr>
-          <p:cNvPr id="98" name="TextBox 97"/>
+          <p:cNvPr id="71" name="TextBox 70"/>
           <p:cNvSpPr txBox="1"/>
           <p:nvPr/>
         </p:nvSpPr>
         <p:spPr>
           <a:xfrm>
-            <a:off x="3108960" y="6355080"/>
-            <a:ext cx="5943600" cy="292608"/>
+            <a:off x="2926080" y="6272784"/>
+            <a:ext cx="6217920" cy="292608"/>
           </a:xfrm>
           <a:prstGeom prst="rect">
             <a:avLst/>
@@ -7451,7 +6130,7 @@
             <a:r>
               <a:rPr sz="900" b="0" i="1">
                 <a:solidFill>
-                  <a:srgbClr val="6B6B6B"/>
+                  <a:srgbClr val="6F6F6F"/>
                 </a:solidFill>
                 <a:latin typeface="Calibri"/>
                 <a:ea typeface="Calibri"/>
@@ -7464,14 +6143,14 @@
       </p:sp>
       <p:sp>
         <p:nvSpPr>
-          <p:cNvPr id="99" name="TextBox 98"/>
+          <p:cNvPr id="72" name="TextBox 71"/>
           <p:cNvSpPr txBox="1"/>
           <p:nvPr/>
         </p:nvSpPr>
         <p:spPr>
           <a:xfrm>
-            <a:off x="11442191" y="6355080"/>
-            <a:ext cx="457200" cy="292608"/>
+            <a:off x="11475719" y="6272784"/>
+            <a:ext cx="365760" cy="292608"/>
           </a:xfrm>
           <a:prstGeom prst="rect">
             <a:avLst/>
@@ -7493,7 +6172,7 @@
             <a:r>
               <a:rPr sz="1100" b="0" i="0">
                 <a:solidFill>
-                  <a:srgbClr val="4A4A4A"/>
+                  <a:srgbClr val="6F6F6F"/>
                 </a:solidFill>
                 <a:latin typeface="Calibri"/>
                 <a:ea typeface="Calibri"/>

</xml_diff>